<commit_message>
Add Nocturne design-system package with lint rules, tokens, and theme templates.
</commit_message>
<xml_diff>
--- a/sesion3/Sesion3_Ecuaciones_Separables.pptx
+++ b/sesion3/Sesion3_Ecuaciones_Separables.pptx
@@ -2498,8 +2498,8 @@
           </a:p>
         </p:txBody>
       </p:sp>
-      <mc:AlternateContent xmlns:mc="http://schemas.openxmlformats.org/markup-compatibility/2006">
-        <mc:Choice xmlns:a14="http://schemas.microsoft.com/office/drawing/2010/main" Requires="a14">
+      <mc:AlternateContent xmlns:mc="http://schemas.openxmlformats.org/markup-compatibility/2006" xmlns:a14="http://schemas.microsoft.com/office/drawing/2010/main">
+        <mc:Choice Requires="a14">
           <p:sp>
             <p:nvSpPr>
               <p:cNvPr id="11" name="Text 9"/>
@@ -2619,7 +2619,7 @@
             </p:txBody>
           </p:sp>
         </mc:Choice>
-        <mc:Fallback>
+        <mc:Fallback xmlns="">
           <p:sp>
             <p:nvSpPr>
               <p:cNvPr id="11" name="Text 9"/>
@@ -2838,8 +2838,8 @@
           </a:p>
         </p:txBody>
       </p:sp>
-      <mc:AlternateContent xmlns:mc="http://schemas.openxmlformats.org/markup-compatibility/2006">
-        <mc:Choice xmlns:a14="http://schemas.microsoft.com/office/drawing/2010/main" Requires="a14">
+      <mc:AlternateContent xmlns:mc="http://schemas.openxmlformats.org/markup-compatibility/2006" xmlns:a14="http://schemas.microsoft.com/office/drawing/2010/main">
+        <mc:Choice Requires="a14">
           <p:sp>
             <p:nvSpPr>
               <p:cNvPr id="5" name="Text 3"/>
@@ -2954,7 +2954,7 @@
             </p:txBody>
           </p:sp>
         </mc:Choice>
-        <mc:Fallback>
+        <mc:Fallback xmlns="">
           <p:sp>
             <p:nvSpPr>
               <p:cNvPr id="5" name="Text 3"/>
@@ -3101,8 +3101,8 @@
           </a:p>
         </p:txBody>
       </p:sp>
-      <mc:AlternateContent xmlns:mc="http://schemas.openxmlformats.org/markup-compatibility/2006">
-        <mc:Choice xmlns:a14="http://schemas.microsoft.com/office/drawing/2010/main" Requires="a14">
+      <mc:AlternateContent xmlns:mc="http://schemas.openxmlformats.org/markup-compatibility/2006" xmlns:a14="http://schemas.microsoft.com/office/drawing/2010/main">
+        <mc:Choice Requires="a14">
           <p:sp>
             <p:nvSpPr>
               <p:cNvPr id="9" name="Text 7"/>
@@ -3205,7 +3205,7 @@
             </p:txBody>
           </p:sp>
         </mc:Choice>
-        <mc:Fallback>
+        <mc:Fallback xmlns="">
           <p:sp>
             <p:nvSpPr>
               <p:cNvPr id="9" name="Text 7"/>
@@ -3245,8 +3245,8 @@
           </p:sp>
         </mc:Fallback>
       </mc:AlternateContent>
-      <mc:AlternateContent xmlns:mc="http://schemas.openxmlformats.org/markup-compatibility/2006">
-        <mc:Choice xmlns:a14="http://schemas.microsoft.com/office/drawing/2010/main" Requires="a14">
+      <mc:AlternateContent xmlns:mc="http://schemas.openxmlformats.org/markup-compatibility/2006" xmlns:a14="http://schemas.microsoft.com/office/drawing/2010/main">
+        <mc:Choice Requires="a14">
           <p:sp>
             <p:nvSpPr>
               <p:cNvPr id="10" name="Text 8"/>
@@ -3365,7 +3365,7 @@
             </p:txBody>
           </p:sp>
         </mc:Choice>
-        <mc:Fallback>
+        <mc:Fallback xmlns="">
           <p:sp>
             <p:nvSpPr>
               <p:cNvPr id="10" name="Text 8"/>
@@ -3512,8 +3512,8 @@
           </a:p>
         </p:txBody>
       </p:sp>
-      <mc:AlternateContent xmlns:mc="http://schemas.openxmlformats.org/markup-compatibility/2006">
-        <mc:Choice xmlns:a14="http://schemas.microsoft.com/office/drawing/2010/main" Requires="a14">
+      <mc:AlternateContent xmlns:mc="http://schemas.openxmlformats.org/markup-compatibility/2006" xmlns:a14="http://schemas.microsoft.com/office/drawing/2010/main">
+        <mc:Choice Requires="a14">
           <p:sp>
             <p:nvSpPr>
               <p:cNvPr id="14" name="Text 12"/>
@@ -3593,7 +3593,7 @@
             </p:txBody>
           </p:sp>
         </mc:Choice>
-        <mc:Fallback>
+        <mc:Fallback xmlns="">
           <p:sp>
             <p:nvSpPr>
               <p:cNvPr id="14" name="Text 12"/>
@@ -3701,8 +3701,8 @@
           </a:p>
         </p:txBody>
       </p:sp>
-      <mc:AlternateContent xmlns:mc="http://schemas.openxmlformats.org/markup-compatibility/2006">
-        <mc:Choice xmlns:a14="http://schemas.microsoft.com/office/drawing/2010/main" Requires="a14">
+      <mc:AlternateContent xmlns:mc="http://schemas.openxmlformats.org/markup-compatibility/2006" xmlns:a14="http://schemas.microsoft.com/office/drawing/2010/main">
+        <mc:Choice Requires="a14">
           <p:sp>
             <p:nvSpPr>
               <p:cNvPr id="17" name="Text 15"/>
@@ -3816,7 +3816,7 @@
             </p:txBody>
           </p:sp>
         </mc:Choice>
-        <mc:Fallback>
+        <mc:Fallback xmlns="">
           <p:sp>
             <p:nvSpPr>
               <p:cNvPr id="17" name="Text 15"/>
@@ -3856,8 +3856,8 @@
           </p:sp>
         </mc:Fallback>
       </mc:AlternateContent>
-      <mc:AlternateContent xmlns:mc="http://schemas.openxmlformats.org/markup-compatibility/2006">
-        <mc:Choice xmlns:a14="http://schemas.microsoft.com/office/drawing/2010/main" Requires="a14">
+      <mc:AlternateContent xmlns:mc="http://schemas.openxmlformats.org/markup-compatibility/2006" xmlns:a14="http://schemas.microsoft.com/office/drawing/2010/main">
+        <mc:Choice Requires="a14">
           <p:sp>
             <p:nvSpPr>
               <p:cNvPr id="18" name="Text 16"/>
@@ -3983,7 +3983,7 @@
             </p:txBody>
           </p:sp>
         </mc:Choice>
-        <mc:Fallback>
+        <mc:Fallback xmlns="">
           <p:sp>
             <p:nvSpPr>
               <p:cNvPr id="18" name="Text 16"/>
@@ -4224,8 +4224,8 @@
           </a:p>
         </p:txBody>
       </p:sp>
-      <mc:AlternateContent xmlns:mc="http://schemas.openxmlformats.org/markup-compatibility/2006">
-        <mc:Choice xmlns:a14="http://schemas.microsoft.com/office/drawing/2010/main" Requires="a14">
+      <mc:AlternateContent xmlns:mc="http://schemas.openxmlformats.org/markup-compatibility/2006" xmlns:a14="http://schemas.microsoft.com/office/drawing/2010/main">
+        <mc:Choice Requires="a14">
           <p:sp>
             <p:nvSpPr>
               <p:cNvPr id="7" name="Text 5"/>
@@ -4328,7 +4328,7 @@
             </p:txBody>
           </p:sp>
         </mc:Choice>
-        <mc:Fallback>
+        <mc:Fallback xmlns="">
           <p:sp>
             <p:nvSpPr>
               <p:cNvPr id="7" name="Text 5"/>
@@ -4589,8 +4589,8 @@
           </a:p>
         </p:txBody>
       </p:sp>
-      <mc:AlternateContent xmlns:mc="http://schemas.openxmlformats.org/markup-compatibility/2006">
-        <mc:Choice xmlns:a14="http://schemas.microsoft.com/office/drawing/2010/main" Requires="a14">
+      <mc:AlternateContent xmlns:mc="http://schemas.openxmlformats.org/markup-compatibility/2006" xmlns:a14="http://schemas.microsoft.com/office/drawing/2010/main">
+        <mc:Choice Requires="a14">
           <p:sp>
             <p:nvSpPr>
               <p:cNvPr id="5" name="Text 3"/>
@@ -4702,7 +4702,7 @@
             </p:txBody>
           </p:sp>
         </mc:Choice>
-        <mc:Fallback>
+        <mc:Fallback xmlns="">
           <p:sp>
             <p:nvSpPr>
               <p:cNvPr id="5" name="Text 3"/>
@@ -4915,8 +4915,8 @@
           </a:p>
         </p:txBody>
       </p:sp>
-      <mc:AlternateContent xmlns:mc="http://schemas.openxmlformats.org/markup-compatibility/2006">
-        <mc:Choice xmlns:a14="http://schemas.microsoft.com/office/drawing/2010/main" Requires="a14">
+      <mc:AlternateContent xmlns:mc="http://schemas.openxmlformats.org/markup-compatibility/2006" xmlns:a14="http://schemas.microsoft.com/office/drawing/2010/main">
+        <mc:Choice Requires="a14">
           <p:sp>
             <p:nvSpPr>
               <p:cNvPr id="11" name="Text 9"/>
@@ -5019,7 +5019,7 @@
             </p:txBody>
           </p:sp>
         </mc:Choice>
-        <mc:Fallback>
+        <mc:Fallback xmlns="">
           <p:sp>
             <p:nvSpPr>
               <p:cNvPr id="11" name="Text 9"/>
@@ -5059,8 +5059,8 @@
           </p:sp>
         </mc:Fallback>
       </mc:AlternateContent>
-      <mc:AlternateContent xmlns:mc="http://schemas.openxmlformats.org/markup-compatibility/2006">
-        <mc:Choice xmlns:a14="http://schemas.microsoft.com/office/drawing/2010/main" Requires="a14">
+      <mc:AlternateContent xmlns:mc="http://schemas.openxmlformats.org/markup-compatibility/2006" xmlns:a14="http://schemas.microsoft.com/office/drawing/2010/main">
+        <mc:Choice Requires="a14">
           <p:sp>
             <p:nvSpPr>
               <p:cNvPr id="12" name="Text 10"/>
@@ -5202,7 +5202,7 @@
             </p:txBody>
           </p:sp>
         </mc:Choice>
-        <mc:Fallback>
+        <mc:Fallback xmlns="">
           <p:sp>
             <p:nvSpPr>
               <p:cNvPr id="12" name="Text 10"/>
@@ -5276,8 +5276,8 @@
           </a:p>
         </p:txBody>
       </p:sp>
-      <mc:AlternateContent xmlns:mc="http://schemas.openxmlformats.org/markup-compatibility/2006">
-        <mc:Choice xmlns:a14="http://schemas.microsoft.com/office/drawing/2010/main" Requires="a14">
+      <mc:AlternateContent xmlns:mc="http://schemas.openxmlformats.org/markup-compatibility/2006" xmlns:a14="http://schemas.microsoft.com/office/drawing/2010/main">
+        <mc:Choice Requires="a14">
           <p:sp>
             <p:nvSpPr>
               <p:cNvPr id="14" name="Text 12"/>
@@ -5449,7 +5449,7 @@
             </p:txBody>
           </p:sp>
         </mc:Choice>
-        <mc:Fallback>
+        <mc:Fallback xmlns="">
           <p:sp>
             <p:nvSpPr>
               <p:cNvPr id="14" name="Text 12"/>
@@ -5670,8 +5670,8 @@
           </a:p>
         </p:txBody>
       </p:sp>
-      <mc:AlternateContent xmlns:mc="http://schemas.openxmlformats.org/markup-compatibility/2006">
-        <mc:Choice xmlns:a14="http://schemas.microsoft.com/office/drawing/2010/main" Requires="a14">
+      <mc:AlternateContent xmlns:mc="http://schemas.openxmlformats.org/markup-compatibility/2006" xmlns:a14="http://schemas.microsoft.com/office/drawing/2010/main">
+        <mc:Choice Requires="a14">
           <p:sp>
             <p:nvSpPr>
               <p:cNvPr id="20" name="Text 18"/>
@@ -5791,7 +5791,7 @@
             </p:txBody>
           </p:sp>
         </mc:Choice>
-        <mc:Fallback>
+        <mc:Fallback xmlns="">
           <p:sp>
             <p:nvSpPr>
               <p:cNvPr id="20" name="Text 18"/>
@@ -5831,8 +5831,8 @@
           </p:sp>
         </mc:Fallback>
       </mc:AlternateContent>
-      <mc:AlternateContent xmlns:mc="http://schemas.openxmlformats.org/markup-compatibility/2006">
-        <mc:Choice xmlns:a14="http://schemas.microsoft.com/office/drawing/2010/main" Requires="a14">
+      <mc:AlternateContent xmlns:mc="http://schemas.openxmlformats.org/markup-compatibility/2006" xmlns:a14="http://schemas.microsoft.com/office/drawing/2010/main">
+        <mc:Choice Requires="a14">
           <p:sp>
             <p:nvSpPr>
               <p:cNvPr id="21" name="Text 19"/>
@@ -6063,7 +6063,7 @@
             </p:txBody>
           </p:sp>
         </mc:Choice>
-        <mc:Fallback>
+        <mc:Fallback xmlns="">
           <p:sp>
             <p:nvSpPr>
               <p:cNvPr id="21" name="Text 19"/>
@@ -6103,8 +6103,8 @@
           </p:sp>
         </mc:Fallback>
       </mc:AlternateContent>
-      <mc:AlternateContent xmlns:mc="http://schemas.openxmlformats.org/markup-compatibility/2006">
-        <mc:Choice xmlns:a14="http://schemas.microsoft.com/office/drawing/2010/main" Requires="a14">
+      <mc:AlternateContent xmlns:mc="http://schemas.openxmlformats.org/markup-compatibility/2006" xmlns:a14="http://schemas.microsoft.com/office/drawing/2010/main">
+        <mc:Choice Requires="a14">
           <p:sp>
             <p:nvSpPr>
               <p:cNvPr id="22" name="Text 20"/>
@@ -6177,7 +6177,7 @@
             </p:txBody>
           </p:sp>
         </mc:Choice>
-        <mc:Fallback>
+        <mc:Fallback xmlns="">
           <p:sp>
             <p:nvSpPr>
               <p:cNvPr id="22" name="Text 20"/>
@@ -6251,8 +6251,8 @@
           </a:p>
         </p:txBody>
       </p:sp>
-      <mc:AlternateContent xmlns:mc="http://schemas.openxmlformats.org/markup-compatibility/2006">
-        <mc:Choice xmlns:a14="http://schemas.microsoft.com/office/drawing/2010/main" Requires="a14">
+      <mc:AlternateContent xmlns:mc="http://schemas.openxmlformats.org/markup-compatibility/2006" xmlns:a14="http://schemas.microsoft.com/office/drawing/2010/main">
+        <mc:Choice Requires="a14">
           <p:sp>
             <p:nvSpPr>
               <p:cNvPr id="24" name="Text 22"/>
@@ -6427,7 +6427,7 @@
             </p:txBody>
           </p:sp>
         </mc:Choice>
-        <mc:Fallback>
+        <mc:Fallback xmlns="">
           <p:sp>
             <p:nvSpPr>
               <p:cNvPr id="24" name="Text 22"/>
@@ -6680,8 +6680,8 @@
           </a:p>
         </p:txBody>
       </p:sp>
-      <mc:AlternateContent xmlns:mc="http://schemas.openxmlformats.org/markup-compatibility/2006">
-        <mc:Choice xmlns:a14="http://schemas.microsoft.com/office/drawing/2010/main" Requires="a14">
+      <mc:AlternateContent xmlns:mc="http://schemas.openxmlformats.org/markup-compatibility/2006" xmlns:a14="http://schemas.microsoft.com/office/drawing/2010/main">
+        <mc:Choice Requires="a14">
           <p:sp>
             <p:nvSpPr>
               <p:cNvPr id="6" name="Text 4"/>
@@ -6884,7 +6884,7 @@
             </p:txBody>
           </p:sp>
         </mc:Choice>
-        <mc:Fallback>
+        <mc:Fallback xmlns="">
           <p:sp>
             <p:nvSpPr>
               <p:cNvPr id="6" name="Text 4"/>
@@ -6992,8 +6992,8 @@
           </a:p>
         </p:txBody>
       </p:sp>
-      <mc:AlternateContent xmlns:mc="http://schemas.openxmlformats.org/markup-compatibility/2006">
-        <mc:Choice xmlns:a14="http://schemas.microsoft.com/office/drawing/2010/main" Requires="a14">
+      <mc:AlternateContent xmlns:mc="http://schemas.openxmlformats.org/markup-compatibility/2006" xmlns:a14="http://schemas.microsoft.com/office/drawing/2010/main">
+        <mc:Choice Requires="a14">
           <p:sp>
             <p:nvSpPr>
               <p:cNvPr id="9" name="Text 7"/>
@@ -7171,7 +7171,7 @@
             </p:txBody>
           </p:sp>
         </mc:Choice>
-        <mc:Fallback>
+        <mc:Fallback xmlns="">
           <p:sp>
             <p:nvSpPr>
               <p:cNvPr id="9" name="Text 7"/>
@@ -7250,8 +7250,8 @@
           </a:p>
         </p:txBody>
       </p:sp>
-      <mc:AlternateContent xmlns:mc="http://schemas.openxmlformats.org/markup-compatibility/2006">
-        <mc:Choice xmlns:a14="http://schemas.microsoft.com/office/drawing/2010/main" Requires="a14">
+      <mc:AlternateContent xmlns:mc="http://schemas.openxmlformats.org/markup-compatibility/2006" xmlns:a14="http://schemas.microsoft.com/office/drawing/2010/main">
+        <mc:Choice Requires="a14">
           <p:sp>
             <p:nvSpPr>
               <p:cNvPr id="11" name="Text 9"/>
@@ -7304,7 +7304,7 @@
             </p:txBody>
           </p:sp>
         </mc:Choice>
-        <mc:Fallback>
+        <mc:Fallback xmlns="">
           <p:sp>
             <p:nvSpPr>
               <p:cNvPr id="11" name="Text 9"/>
@@ -7653,8 +7653,8 @@
           </a:p>
         </p:txBody>
       </p:sp>
-      <mc:AlternateContent xmlns:mc="http://schemas.openxmlformats.org/markup-compatibility/2006">
-        <mc:Choice xmlns:a14="http://schemas.microsoft.com/office/drawing/2010/main" Requires="a14">
+      <mc:AlternateContent xmlns:mc="http://schemas.openxmlformats.org/markup-compatibility/2006" xmlns:a14="http://schemas.microsoft.com/office/drawing/2010/main">
+        <mc:Choice Requires="a14">
           <p:sp>
             <p:nvSpPr>
               <p:cNvPr id="7" name="Text 5"/>
@@ -7859,7 +7859,7 @@
             </p:txBody>
           </p:sp>
         </mc:Choice>
-        <mc:Fallback>
+        <mc:Fallback xmlns="">
           <p:sp>
             <p:nvSpPr>
               <p:cNvPr id="7" name="Text 5"/>
@@ -8120,8 +8120,8 @@
           </a:p>
         </p:txBody>
       </p:sp>
-      <mc:AlternateContent xmlns:mc="http://schemas.openxmlformats.org/markup-compatibility/2006">
-        <mc:Choice xmlns:a14="http://schemas.microsoft.com/office/drawing/2010/main" Requires="a14">
+      <mc:AlternateContent xmlns:mc="http://schemas.openxmlformats.org/markup-compatibility/2006" xmlns:a14="http://schemas.microsoft.com/office/drawing/2010/main">
+        <mc:Choice Requires="a14">
           <p:sp>
             <p:nvSpPr>
               <p:cNvPr id="5" name="Text 3"/>
@@ -8326,7 +8326,7 @@
             </p:txBody>
           </p:sp>
         </mc:Choice>
-        <mc:Fallback>
+        <mc:Fallback xmlns="">
           <p:sp>
             <p:nvSpPr>
               <p:cNvPr id="5" name="Text 3"/>
@@ -8439,8 +8439,8 @@
           </a:p>
         </p:txBody>
       </p:sp>
-      <mc:AlternateContent xmlns:mc="http://schemas.openxmlformats.org/markup-compatibility/2006">
-        <mc:Choice xmlns:a14="http://schemas.microsoft.com/office/drawing/2010/main" Requires="a14">
+      <mc:AlternateContent xmlns:mc="http://schemas.openxmlformats.org/markup-compatibility/2006" xmlns:a14="http://schemas.microsoft.com/office/drawing/2010/main">
+        <mc:Choice Requires="a14">
           <p:sp>
             <p:nvSpPr>
               <p:cNvPr id="8" name="Text 6"/>
@@ -8558,7 +8558,7 @@
             </p:txBody>
           </p:sp>
         </mc:Choice>
-        <mc:Fallback>
+        <mc:Fallback xmlns="">
           <p:sp>
             <p:nvSpPr>
               <p:cNvPr id="8" name="Text 6"/>
@@ -8598,8 +8598,8 @@
           </p:sp>
         </mc:Fallback>
       </mc:AlternateContent>
-      <mc:AlternateContent xmlns:mc="http://schemas.openxmlformats.org/markup-compatibility/2006">
-        <mc:Choice xmlns:a14="http://schemas.microsoft.com/office/drawing/2010/main" Requires="a14">
+      <mc:AlternateContent xmlns:mc="http://schemas.openxmlformats.org/markup-compatibility/2006" xmlns:a14="http://schemas.microsoft.com/office/drawing/2010/main">
+        <mc:Choice Requires="a14">
           <p:sp>
             <p:nvSpPr>
               <p:cNvPr id="9" name="Text 7"/>
@@ -8747,7 +8747,7 @@
             </p:txBody>
           </p:sp>
         </mc:Choice>
-        <mc:Fallback>
+        <mc:Fallback xmlns="">
           <p:sp>
             <p:nvSpPr>
               <p:cNvPr id="9" name="Text 7"/>
@@ -8826,8 +8826,8 @@
           </a:p>
         </p:txBody>
       </p:sp>
-      <mc:AlternateContent xmlns:mc="http://schemas.openxmlformats.org/markup-compatibility/2006">
-        <mc:Choice xmlns:a14="http://schemas.microsoft.com/office/drawing/2010/main" Requires="a14">
+      <mc:AlternateContent xmlns:mc="http://schemas.openxmlformats.org/markup-compatibility/2006" xmlns:a14="http://schemas.microsoft.com/office/drawing/2010/main">
+        <mc:Choice Requires="a14">
           <p:sp>
             <p:nvSpPr>
               <p:cNvPr id="11" name="Text 9"/>
@@ -8975,7 +8975,7 @@
             </p:txBody>
           </p:sp>
         </mc:Choice>
-        <mc:Fallback>
+        <mc:Fallback xmlns="">
           <p:sp>
             <p:nvSpPr>
               <p:cNvPr id="11" name="Text 9"/>
@@ -9015,8 +9015,8 @@
           </p:sp>
         </mc:Fallback>
       </mc:AlternateContent>
-      <mc:AlternateContent xmlns:mc="http://schemas.openxmlformats.org/markup-compatibility/2006">
-        <mc:Choice xmlns:a14="http://schemas.microsoft.com/office/drawing/2010/main" Requires="a14">
+      <mc:AlternateContent xmlns:mc="http://schemas.openxmlformats.org/markup-compatibility/2006" xmlns:a14="http://schemas.microsoft.com/office/drawing/2010/main">
+        <mc:Choice Requires="a14">
           <p:sp>
             <p:nvSpPr>
               <p:cNvPr id="12" name="Text 10"/>
@@ -9164,7 +9164,7 @@
             </p:txBody>
           </p:sp>
         </mc:Choice>
-        <mc:Fallback>
+        <mc:Fallback xmlns="">
           <p:sp>
             <p:nvSpPr>
               <p:cNvPr id="12" name="Text 10"/>
@@ -9204,8 +9204,8 @@
           </p:sp>
         </mc:Fallback>
       </mc:AlternateContent>
-      <mc:AlternateContent xmlns:mc="http://schemas.openxmlformats.org/markup-compatibility/2006">
-        <mc:Choice xmlns:a14="http://schemas.microsoft.com/office/drawing/2010/main" Requires="a14">
+      <mc:AlternateContent xmlns:mc="http://schemas.openxmlformats.org/markup-compatibility/2006" xmlns:a14="http://schemas.microsoft.com/office/drawing/2010/main">
+        <mc:Choice Requires="a14">
           <p:sp>
             <p:nvSpPr>
               <p:cNvPr id="13" name="Text 11"/>
@@ -9285,7 +9285,7 @@
             </p:txBody>
           </p:sp>
         </mc:Choice>
-        <mc:Fallback>
+        <mc:Fallback xmlns="">
           <p:sp>
             <p:nvSpPr>
               <p:cNvPr id="13" name="Text 11"/>
@@ -9432,8 +9432,8 @@
           </a:p>
         </p:txBody>
       </p:sp>
-      <mc:AlternateContent xmlns:mc="http://schemas.openxmlformats.org/markup-compatibility/2006">
-        <mc:Choice xmlns:a14="http://schemas.microsoft.com/office/drawing/2010/main" Requires="a14">
+      <mc:AlternateContent xmlns:mc="http://schemas.openxmlformats.org/markup-compatibility/2006" xmlns:a14="http://schemas.microsoft.com/office/drawing/2010/main">
+        <mc:Choice Requires="a14">
           <p:sp>
             <p:nvSpPr>
               <p:cNvPr id="17" name="Text 15"/>
@@ -9575,7 +9575,7 @@
             </p:txBody>
           </p:sp>
         </mc:Choice>
-        <mc:Fallback>
+        <mc:Fallback xmlns="">
           <p:sp>
             <p:nvSpPr>
               <p:cNvPr id="17" name="Text 15"/>
@@ -9935,8 +9935,8 @@
           </a:p>
         </p:txBody>
       </p:sp>
-      <mc:AlternateContent xmlns:mc="http://schemas.openxmlformats.org/markup-compatibility/2006">
-        <mc:Choice xmlns:a14="http://schemas.microsoft.com/office/drawing/2010/main" Requires="a14">
+      <mc:AlternateContent xmlns:mc="http://schemas.openxmlformats.org/markup-compatibility/2006" xmlns:a14="http://schemas.microsoft.com/office/drawing/2010/main">
+        <mc:Choice Requires="a14">
           <p:sp>
             <p:nvSpPr>
               <p:cNvPr id="8" name="Text 5"/>
@@ -10108,7 +10108,7 @@
             </p:txBody>
           </p:sp>
         </mc:Choice>
-        <mc:Fallback>
+        <mc:Fallback xmlns="">
           <p:sp>
             <p:nvSpPr>
               <p:cNvPr id="8" name="Text 5"/>
@@ -10466,8 +10466,8 @@
           </a:p>
         </p:txBody>
       </p:sp>
-      <mc:AlternateContent xmlns:mc="http://schemas.openxmlformats.org/markup-compatibility/2006">
-        <mc:Choice xmlns:a14="http://schemas.microsoft.com/office/drawing/2010/main" Requires="a14">
+      <mc:AlternateContent xmlns:mc="http://schemas.openxmlformats.org/markup-compatibility/2006" xmlns:a14="http://schemas.microsoft.com/office/drawing/2010/main">
+        <mc:Choice Requires="a14">
           <p:sp>
             <p:nvSpPr>
               <p:cNvPr id="7" name="Text 5"/>
@@ -10619,7 +10619,7 @@
             </p:txBody>
           </p:sp>
         </mc:Choice>
-        <mc:Fallback>
+        <mc:Fallback xmlns="">
           <p:sp>
             <p:nvSpPr>
               <p:cNvPr id="7" name="Text 5"/>
@@ -10880,8 +10880,8 @@
           </a:p>
         </p:txBody>
       </p:sp>
-      <mc:AlternateContent xmlns:mc="http://schemas.openxmlformats.org/markup-compatibility/2006">
-        <mc:Choice xmlns:a14="http://schemas.microsoft.com/office/drawing/2010/main" Requires="a14">
+      <mc:AlternateContent xmlns:mc="http://schemas.openxmlformats.org/markup-compatibility/2006" xmlns:a14="http://schemas.microsoft.com/office/drawing/2010/main">
+        <mc:Choice Requires="a14">
           <p:sp>
             <p:nvSpPr>
               <p:cNvPr id="5" name="Text 3"/>
@@ -11021,7 +11021,7 @@
             </p:txBody>
           </p:sp>
         </mc:Choice>
-        <mc:Fallback>
+        <mc:Fallback xmlns="">
           <p:sp>
             <p:nvSpPr>
               <p:cNvPr id="5" name="Text 3"/>
@@ -11095,8 +11095,8 @@
           </a:p>
         </p:txBody>
       </p:sp>
-      <mc:AlternateContent xmlns:mc="http://schemas.openxmlformats.org/markup-compatibility/2006">
-        <mc:Choice xmlns:a14="http://schemas.microsoft.com/office/drawing/2010/main" Requires="a14">
+      <mc:AlternateContent xmlns:mc="http://schemas.openxmlformats.org/markup-compatibility/2006" xmlns:a14="http://schemas.microsoft.com/office/drawing/2010/main">
+        <mc:Choice Requires="a14">
           <p:sp>
             <p:nvSpPr>
               <p:cNvPr id="7" name="Text 5"/>
@@ -11214,7 +11214,7 @@
             </p:txBody>
           </p:sp>
         </mc:Choice>
-        <mc:Fallback>
+        <mc:Fallback xmlns="">
           <p:sp>
             <p:nvSpPr>
               <p:cNvPr id="7" name="Text 5"/>
@@ -11254,8 +11254,8 @@
           </p:sp>
         </mc:Fallback>
       </mc:AlternateContent>
-      <mc:AlternateContent xmlns:mc="http://schemas.openxmlformats.org/markup-compatibility/2006">
-        <mc:Choice xmlns:a14="http://schemas.microsoft.com/office/drawing/2010/main" Requires="a14">
+      <mc:AlternateContent xmlns:mc="http://schemas.openxmlformats.org/markup-compatibility/2006" xmlns:a14="http://schemas.microsoft.com/office/drawing/2010/main">
+        <mc:Choice Requires="a14">
           <p:sp>
             <p:nvSpPr>
               <p:cNvPr id="8" name="Text 6"/>
@@ -11434,7 +11434,7 @@
             </p:txBody>
           </p:sp>
         </mc:Choice>
-        <mc:Fallback>
+        <mc:Fallback xmlns="">
           <p:sp>
             <p:nvSpPr>
               <p:cNvPr id="8" name="Text 6"/>
@@ -11542,8 +11542,8 @@
           </a:p>
         </p:txBody>
       </p:sp>
-      <mc:AlternateContent xmlns:mc="http://schemas.openxmlformats.org/markup-compatibility/2006">
-        <mc:Choice xmlns:a14="http://schemas.microsoft.com/office/drawing/2010/main" Requires="a14">
+      <mc:AlternateContent xmlns:mc="http://schemas.openxmlformats.org/markup-compatibility/2006" xmlns:a14="http://schemas.microsoft.com/office/drawing/2010/main">
+        <mc:Choice Requires="a14">
           <p:sp>
             <p:nvSpPr>
               <p:cNvPr id="11" name="Text 9"/>
@@ -11693,7 +11693,7 @@
             </p:txBody>
           </p:sp>
         </mc:Choice>
-        <mc:Fallback>
+        <mc:Fallback xmlns="">
           <p:sp>
             <p:nvSpPr>
               <p:cNvPr id="11" name="Text 9"/>
@@ -11872,8 +11872,8 @@
           </a:p>
         </p:txBody>
       </p:sp>
-      <mc:AlternateContent xmlns:mc="http://schemas.openxmlformats.org/markup-compatibility/2006">
-        <mc:Choice xmlns:a14="http://schemas.microsoft.com/office/drawing/2010/main" Requires="a14">
+      <mc:AlternateContent xmlns:mc="http://schemas.openxmlformats.org/markup-compatibility/2006" xmlns:a14="http://schemas.microsoft.com/office/drawing/2010/main">
+        <mc:Choice Requires="a14">
           <p:sp>
             <p:nvSpPr>
               <p:cNvPr id="16" name="Text 14"/>
@@ -12074,7 +12074,7 @@
             </p:txBody>
           </p:sp>
         </mc:Choice>
-        <mc:Fallback>
+        <mc:Fallback xmlns="">
           <p:sp>
             <p:nvSpPr>
               <p:cNvPr id="16" name="Text 14"/>
@@ -12180,8 +12180,8 @@
           </a:p>
         </p:txBody>
       </p:sp>
-      <mc:AlternateContent xmlns:mc="http://schemas.openxmlformats.org/markup-compatibility/2006">
-        <mc:Choice xmlns:a14="http://schemas.microsoft.com/office/drawing/2010/main" Requires="a14">
+      <mc:AlternateContent xmlns:mc="http://schemas.openxmlformats.org/markup-compatibility/2006" xmlns:a14="http://schemas.microsoft.com/office/drawing/2010/main">
+        <mc:Choice Requires="a14">
           <p:sp>
             <p:nvSpPr>
               <p:cNvPr id="19" name="Text 17"/>
@@ -12333,7 +12333,7 @@
             </p:txBody>
           </p:sp>
         </mc:Choice>
-        <mc:Fallback>
+        <mc:Fallback xmlns="">
           <p:sp>
             <p:nvSpPr>
               <p:cNvPr id="19" name="Text 17"/>
@@ -12439,8 +12439,8 @@
           </a:p>
         </p:txBody>
       </p:sp>
-      <mc:AlternateContent xmlns:mc="http://schemas.openxmlformats.org/markup-compatibility/2006">
-        <mc:Choice xmlns:a14="http://schemas.microsoft.com/office/drawing/2010/main" Requires="a14">
+      <mc:AlternateContent xmlns:mc="http://schemas.openxmlformats.org/markup-compatibility/2006" xmlns:a14="http://schemas.microsoft.com/office/drawing/2010/main">
+        <mc:Choice Requires="a14">
           <p:sp>
             <p:nvSpPr>
               <p:cNvPr id="22" name="Text 20"/>
@@ -12534,7 +12534,7 @@
             </p:txBody>
           </p:sp>
         </mc:Choice>
-        <mc:Fallback>
+        <mc:Fallback xmlns="">
           <p:sp>
             <p:nvSpPr>
               <p:cNvPr id="22" name="Text 20"/>
@@ -13008,8 +13008,8 @@
           </a:p>
         </p:txBody>
       </p:sp>
-      <mc:AlternateContent xmlns:mc="http://schemas.openxmlformats.org/markup-compatibility/2006">
-        <mc:Choice xmlns:a14="http://schemas.microsoft.com/office/drawing/2010/main" Requires="a14">
+      <mc:AlternateContent xmlns:mc="http://schemas.openxmlformats.org/markup-compatibility/2006" xmlns:a14="http://schemas.microsoft.com/office/drawing/2010/main">
+        <mc:Choice Requires="a14">
           <p:sp>
             <p:nvSpPr>
               <p:cNvPr id="9" name="Text 7"/>
@@ -13097,7 +13097,7 @@
             </p:txBody>
           </p:sp>
         </mc:Choice>
-        <mc:Fallback>
+        <mc:Fallback xmlns="">
           <p:sp>
             <p:nvSpPr>
               <p:cNvPr id="9" name="Text 7"/>
@@ -13773,8 +13773,8 @@
           </a:p>
         </p:txBody>
       </p:sp>
-      <mc:AlternateContent xmlns:mc="http://schemas.openxmlformats.org/markup-compatibility/2006">
-        <mc:Choice xmlns:a14="http://schemas.microsoft.com/office/drawing/2010/main" Requires="a14">
+      <mc:AlternateContent xmlns:mc="http://schemas.openxmlformats.org/markup-compatibility/2006" xmlns:a14="http://schemas.microsoft.com/office/drawing/2010/main">
+        <mc:Choice Requires="a14">
           <p:sp>
             <p:nvSpPr>
               <p:cNvPr id="7" name="Text 5"/>
@@ -13818,84 +13818,70 @@
                   </a:rPr>
                   <a:t>Una ED de primer orden </a:t>
                 </a:r>
-                <mc:AlternateContent>
-                  <mc:Choice Requires="a14">
-                    <a14:m>
-                      <m:oMath xmlns:m="http://schemas.openxmlformats.org/officeDocument/2006/math">
-                        <m:r>
-                          <a:rPr>
-                            <a:latin typeface="Cambria Math" panose="02040503050406030204" pitchFamily="18" charset="0"/>
-                          </a:rPr>
-                          <m:t>𝑑𝑦</m:t>
-                        </m:r>
-                        <m:r>
-                          <a:rPr>
-                            <a:latin typeface="Cambria Math" panose="02040503050406030204" pitchFamily="18" charset="0"/>
-                          </a:rPr>
-                          <m:t>/</m:t>
-                        </m:r>
-                        <m:r>
-                          <a:rPr>
-                            <a:latin typeface="Cambria Math" panose="02040503050406030204" pitchFamily="18" charset="0"/>
-                          </a:rPr>
-                          <m:t>𝑑𝑥</m:t>
-                        </m:r>
-                        <m:r>
-                          <a:rPr>
-                            <a:latin typeface="Cambria Math" panose="02040503050406030204" pitchFamily="18" charset="0"/>
-                          </a:rPr>
-                          <m:t>=</m:t>
-                        </m:r>
-                        <m:r>
-                          <a:rPr>
-                            <a:latin typeface="Cambria Math" panose="02040503050406030204" pitchFamily="18" charset="0"/>
-                          </a:rPr>
-                          <m:t>𝑓</m:t>
-                        </m:r>
-                        <m:r>
-                          <a:rPr>
-                            <a:latin typeface="Cambria Math" panose="02040503050406030204" pitchFamily="18" charset="0"/>
-                          </a:rPr>
-                          <m:t>(</m:t>
-                        </m:r>
-                        <m:r>
-                          <a:rPr>
-                            <a:latin typeface="Cambria Math" panose="02040503050406030204" pitchFamily="18" charset="0"/>
-                          </a:rPr>
-                          <m:t>𝑥</m:t>
-                        </m:r>
-                        <m:r>
-                          <a:rPr>
-                            <a:latin typeface="Cambria Math" panose="02040503050406030204" pitchFamily="18" charset="0"/>
-                          </a:rPr>
-                          <m:t>,</m:t>
-                        </m:r>
-                        <m:r>
-                          <a:rPr>
-                            <a:latin typeface="Cambria Math" panose="02040503050406030204" pitchFamily="18" charset="0"/>
-                          </a:rPr>
-                          <m:t>𝑦</m:t>
-                        </m:r>
-                        <m:r>
-                          <a:rPr>
-                            <a:latin typeface="Cambria Math" panose="02040503050406030204" pitchFamily="18" charset="0"/>
-                          </a:rPr>
-                          <m:t>)</m:t>
-                        </m:r>
-                      </m:oMath>
-                    </a14:m>
-                  </mc:Choice>
-                  <mc:Fallback xmlns="">
-                    <a:r>
-                      <a:rPr lang="es-MX" sz="1450">
-                        <a:solidFill>
-                          <a:srgbClr val="334155"/>
-                        </a:solidFill>
+                <a14:m>
+                  <m:oMath xmlns:m="http://schemas.openxmlformats.org/officeDocument/2006/math">
+                    <m:r>
+                      <a:rPr>
+                        <a:latin typeface="Cambria Math" panose="02040503050406030204" pitchFamily="18" charset="0"/>
                       </a:rPr>
-                      <a:t>dy/dx = f(x,y)</a:t>
-                    </a:r>
-                  </mc:Fallback>
-                </mc:AlternateContent>
+                      <m:t>𝑑𝑦</m:t>
+                    </m:r>
+                    <m:r>
+                      <a:rPr>
+                        <a:latin typeface="Cambria Math" panose="02040503050406030204" pitchFamily="18" charset="0"/>
+                      </a:rPr>
+                      <m:t>/</m:t>
+                    </m:r>
+                    <m:r>
+                      <a:rPr>
+                        <a:latin typeface="Cambria Math" panose="02040503050406030204" pitchFamily="18" charset="0"/>
+                      </a:rPr>
+                      <m:t>𝑑𝑥</m:t>
+                    </m:r>
+                    <m:r>
+                      <a:rPr>
+                        <a:latin typeface="Cambria Math" panose="02040503050406030204" pitchFamily="18" charset="0"/>
+                      </a:rPr>
+                      <m:t>=</m:t>
+                    </m:r>
+                    <m:r>
+                      <a:rPr>
+                        <a:latin typeface="Cambria Math" panose="02040503050406030204" pitchFamily="18" charset="0"/>
+                      </a:rPr>
+                      <m:t>𝑓</m:t>
+                    </m:r>
+                    <m:r>
+                      <a:rPr>
+                        <a:latin typeface="Cambria Math" panose="02040503050406030204" pitchFamily="18" charset="0"/>
+                      </a:rPr>
+                      <m:t>(</m:t>
+                    </m:r>
+                    <m:r>
+                      <a:rPr>
+                        <a:latin typeface="Cambria Math" panose="02040503050406030204" pitchFamily="18" charset="0"/>
+                      </a:rPr>
+                      <m:t>𝑥</m:t>
+                    </m:r>
+                    <m:r>
+                      <a:rPr>
+                        <a:latin typeface="Cambria Math" panose="02040503050406030204" pitchFamily="18" charset="0"/>
+                      </a:rPr>
+                      <m:t>,</m:t>
+                    </m:r>
+                    <m:r>
+                      <a:rPr>
+                        <a:latin typeface="Cambria Math" panose="02040503050406030204" pitchFamily="18" charset="0"/>
+                      </a:rPr>
+                      <m:t>𝑦</m:t>
+                    </m:r>
+                    <m:r>
+                      <a:rPr>
+                        <a:latin typeface="Cambria Math" panose="02040503050406030204" pitchFamily="18" charset="0"/>
+                      </a:rPr>
+                      <m:t>)</m:t>
+                    </m:r>
+                  </m:oMath>
+                </a14:m>
                 <a:r>
                   <a:rPr lang="en-US" sz="1450" dirty="0">
                     <a:solidFill>
@@ -13907,48 +13893,34 @@
                   </a:rPr>
                   <a:t> es separable si su lado derecho puede factorizarse como el producto de una función que depende solo de x por una función que depende solo de y. Dividiendo entre </a:t>
                 </a:r>
-                <mc:AlternateContent>
-                  <mc:Choice Requires="a14">
-                    <a14:m>
-                      <m:oMath xmlns:m="http://schemas.openxmlformats.org/officeDocument/2006/math">
-                        <m:r>
-                          <a:rPr>
-                            <a:latin typeface="Cambria Math" panose="02040503050406030204" pitchFamily="18" charset="0"/>
-                          </a:rPr>
-                          <m:t>ℎ</m:t>
-                        </m:r>
-                        <m:r>
-                          <a:rPr>
-                            <a:latin typeface="Cambria Math" panose="02040503050406030204" pitchFamily="18" charset="0"/>
-                          </a:rPr>
-                          <m:t>(</m:t>
-                        </m:r>
-                        <m:r>
-                          <a:rPr>
-                            <a:latin typeface="Cambria Math" panose="02040503050406030204" pitchFamily="18" charset="0"/>
-                          </a:rPr>
-                          <m:t>𝑦</m:t>
-                        </m:r>
-                        <m:r>
-                          <a:rPr>
-                            <a:latin typeface="Cambria Math" panose="02040503050406030204" pitchFamily="18" charset="0"/>
-                          </a:rPr>
-                          <m:t>)≠0</m:t>
-                        </m:r>
-                      </m:oMath>
-                    </a14:m>
-                  </mc:Choice>
-                  <mc:Fallback xmlns="">
-                    <a:r>
-                      <a:rPr lang="es-MX" sz="1450">
-                        <a:solidFill>
-                          <a:srgbClr val="334155"/>
-                        </a:solidFill>
+                <a14:m>
+                  <m:oMath xmlns:m="http://schemas.openxmlformats.org/officeDocument/2006/math">
+                    <m:r>
+                      <a:rPr>
+                        <a:latin typeface="Cambria Math" panose="02040503050406030204" pitchFamily="18" charset="0"/>
                       </a:rPr>
-                      <a:t>h(y) \neq 0</a:t>
-                    </a:r>
-                  </mc:Fallback>
-                </mc:AlternateContent>
+                      <m:t>ℎ</m:t>
+                    </m:r>
+                    <m:r>
+                      <a:rPr>
+                        <a:latin typeface="Cambria Math" panose="02040503050406030204" pitchFamily="18" charset="0"/>
+                      </a:rPr>
+                      <m:t>(</m:t>
+                    </m:r>
+                    <m:r>
+                      <a:rPr>
+                        <a:latin typeface="Cambria Math" panose="02040503050406030204" pitchFamily="18" charset="0"/>
+                      </a:rPr>
+                      <m:t>𝑦</m:t>
+                    </m:r>
+                    <m:r>
+                      <a:rPr>
+                        <a:latin typeface="Cambria Math" panose="02040503050406030204" pitchFamily="18" charset="0"/>
+                      </a:rPr>
+                      <m:t>)≠0</m:t>
+                    </m:r>
+                  </m:oMath>
+                </a14:m>
                 <a:r>
                   <a:rPr lang="en-US" sz="1450" dirty="0">
                     <a:solidFill>
@@ -13965,7 +13937,7 @@
             </p:txBody>
           </p:sp>
         </mc:Choice>
-        <mc:Fallback>
+        <mc:Fallback xmlns="">
           <p:sp>
             <p:nvSpPr>
               <p:cNvPr id="7" name="Text 5"/>
@@ -14039,8 +14011,8 @@
           </a:p>
         </p:txBody>
       </p:sp>
-      <mc:AlternateContent xmlns:mc="http://schemas.openxmlformats.org/markup-compatibility/2006">
-        <mc:Choice xmlns:a14="http://schemas.microsoft.com/office/drawing/2010/main" Requires="a14">
+      <mc:AlternateContent xmlns:mc="http://schemas.openxmlformats.org/markup-compatibility/2006" xmlns:a14="http://schemas.microsoft.com/office/drawing/2010/main">
+        <mc:Choice Requires="a14">
           <p:sp>
             <p:nvSpPr>
               <p:cNvPr id="9" name="Text 7"/>
@@ -14070,111 +14042,97 @@
                     </a:solidFill>
                   </a:defRPr>
                 </a:pPr>
-                <mc:AlternateContent>
-                  <mc:Choice Requires="a14">
-                    <a14:m>
-                      <m:oMathPara xmlns:m="http://schemas.openxmlformats.org/officeDocument/2006/math">
-                        <m:oMath>
-                          <m:f>
-                            <m:fPr>
-                              <m:ctrlPr>
-                                <a:rPr>
-                                  <a:latin typeface="Cambria Math" panose="02040503050406030204" pitchFamily="18" charset="0"/>
-                                </a:rPr>
-                              </m:ctrlPr>
-                            </m:fPr>
-                            <m:num>
-                              <m:r>
-                                <a:rPr>
-                                  <a:latin typeface="Cambria Math" panose="02040503050406030204" pitchFamily="18" charset="0"/>
-                                </a:rPr>
-                                <m:t>𝑑𝑦</m:t>
-                              </m:r>
-                            </m:num>
-                            <m:den>
-                              <m:r>
-                                <a:rPr>
-                                  <a:latin typeface="Cambria Math" panose="02040503050406030204" pitchFamily="18" charset="0"/>
-                                </a:rPr>
-                                <m:t>𝑑𝑥</m:t>
-                              </m:r>
-                            </m:den>
-                          </m:f>
+                <a14:m>
+                  <m:oMathPara xmlns:m="http://schemas.openxmlformats.org/officeDocument/2006/math">
+                    <m:oMath>
+                      <m:f>
+                        <m:fPr>
+                          <m:ctrlPr>
+                            <a:rPr>
+                              <a:latin typeface="Cambria Math" panose="02040503050406030204" pitchFamily="18" charset="0"/>
+                            </a:rPr>
+                          </m:ctrlPr>
+                        </m:fPr>
+                        <m:num>
                           <m:r>
                             <a:rPr>
                               <a:latin typeface="Cambria Math" panose="02040503050406030204" pitchFamily="18" charset="0"/>
                             </a:rPr>
-                            <m:t>=</m:t>
+                            <m:t>𝑑𝑦</m:t>
                           </m:r>
+                        </m:num>
+                        <m:den>
                           <m:r>
                             <a:rPr>
                               <a:latin typeface="Cambria Math" panose="02040503050406030204" pitchFamily="18" charset="0"/>
                             </a:rPr>
-                            <m:t>𝑔</m:t>
+                            <m:t>𝑑𝑥</m:t>
                           </m:r>
-                          <m:r>
-                            <a:rPr>
-                              <a:latin typeface="Cambria Math" panose="02040503050406030204" pitchFamily="18" charset="0"/>
-                            </a:rPr>
-                            <m:t>(</m:t>
-                          </m:r>
-                          <m:r>
-                            <a:rPr>
-                              <a:latin typeface="Cambria Math" panose="02040503050406030204" pitchFamily="18" charset="0"/>
-                            </a:rPr>
-                            <m:t>𝑥</m:t>
-                          </m:r>
-                          <m:r>
-                            <a:rPr>
-                              <a:latin typeface="Cambria Math" panose="02040503050406030204" pitchFamily="18" charset="0"/>
-                            </a:rPr>
-                            <m:t>)</m:t>
-                          </m:r>
-                          <m:r>
-                            <a:rPr>
-                              <a:latin typeface="Cambria Math" panose="02040503050406030204" pitchFamily="18" charset="0"/>
-                            </a:rPr>
-                            <m:t>ℎ</m:t>
-                          </m:r>
-                          <m:r>
-                            <a:rPr>
-                              <a:latin typeface="Cambria Math" panose="02040503050406030204" pitchFamily="18" charset="0"/>
-                            </a:rPr>
-                            <m:t>(</m:t>
-                          </m:r>
-                          <m:r>
-                            <a:rPr>
-                              <a:latin typeface="Cambria Math" panose="02040503050406030204" pitchFamily="18" charset="0"/>
-                            </a:rPr>
-                            <m:t>𝑦</m:t>
-                          </m:r>
-                          <m:r>
-                            <a:rPr>
-                              <a:latin typeface="Cambria Math" panose="02040503050406030204" pitchFamily="18" charset="0"/>
-                            </a:rPr>
-                            <m:t>)</m:t>
-                          </m:r>
-                        </m:oMath>
-                      </m:oMathPara>
-                    </a14:m>
-                  </mc:Choice>
-                  <mc:Fallback xmlns="">
-                    <a:r>
-                      <a:rPr lang="es-MX" sz="2600">
-                        <a:solidFill>
-                          <a:srgbClr val="0F172A"/>
-                        </a:solidFill>
-                      </a:rPr>
-                      <a:t>\frac{dy}{dx} = g(x)\,h(y)</a:t>
-                    </a:r>
-                  </mc:Fallback>
-                </mc:AlternateContent>
+                        </m:den>
+                      </m:f>
+                      <m:r>
+                        <a:rPr>
+                          <a:latin typeface="Cambria Math" panose="02040503050406030204" pitchFamily="18" charset="0"/>
+                        </a:rPr>
+                        <m:t>=</m:t>
+                      </m:r>
+                      <m:r>
+                        <a:rPr>
+                          <a:latin typeface="Cambria Math" panose="02040503050406030204" pitchFamily="18" charset="0"/>
+                        </a:rPr>
+                        <m:t>𝑔</m:t>
+                      </m:r>
+                      <m:r>
+                        <a:rPr>
+                          <a:latin typeface="Cambria Math" panose="02040503050406030204" pitchFamily="18" charset="0"/>
+                        </a:rPr>
+                        <m:t>(</m:t>
+                      </m:r>
+                      <m:r>
+                        <a:rPr>
+                          <a:latin typeface="Cambria Math" panose="02040503050406030204" pitchFamily="18" charset="0"/>
+                        </a:rPr>
+                        <m:t>𝑥</m:t>
+                      </m:r>
+                      <m:r>
+                        <a:rPr>
+                          <a:latin typeface="Cambria Math" panose="02040503050406030204" pitchFamily="18" charset="0"/>
+                        </a:rPr>
+                        <m:t>)</m:t>
+                      </m:r>
+                      <m:r>
+                        <a:rPr>
+                          <a:latin typeface="Cambria Math" panose="02040503050406030204" pitchFamily="18" charset="0"/>
+                        </a:rPr>
+                        <m:t>ℎ</m:t>
+                      </m:r>
+                      <m:r>
+                        <a:rPr>
+                          <a:latin typeface="Cambria Math" panose="02040503050406030204" pitchFamily="18" charset="0"/>
+                        </a:rPr>
+                        <m:t>(</m:t>
+                      </m:r>
+                      <m:r>
+                        <a:rPr>
+                          <a:latin typeface="Cambria Math" panose="02040503050406030204" pitchFamily="18" charset="0"/>
+                        </a:rPr>
+                        <m:t>𝑦</m:t>
+                      </m:r>
+                      <m:r>
+                        <a:rPr>
+                          <a:latin typeface="Cambria Math" panose="02040503050406030204" pitchFamily="18" charset="0"/>
+                        </a:rPr>
+                        <m:t>)</m:t>
+                      </m:r>
+                    </m:oMath>
+                  </m:oMathPara>
+                </a14:m>
                 <a:endParaRPr lang="en-US" sz="2600" dirty="0"/>
               </a:p>
             </p:txBody>
           </p:sp>
         </mc:Choice>
-        <mc:Fallback>
+        <mc:Fallback xmlns="">
           <p:sp>
             <p:nvSpPr>
               <p:cNvPr id="9" name="Text 7"/>
@@ -14248,8 +14206,8 @@
           </a:p>
         </p:txBody>
       </p:sp>
-      <mc:AlternateContent xmlns:mc="http://schemas.openxmlformats.org/markup-compatibility/2006">
-        <mc:Choice xmlns:a14="http://schemas.microsoft.com/office/drawing/2010/main" Requires="a14">
+      <mc:AlternateContent xmlns:mc="http://schemas.openxmlformats.org/markup-compatibility/2006" xmlns:a14="http://schemas.microsoft.com/office/drawing/2010/main">
+        <mc:Choice Requires="a14">
           <p:sp>
             <p:nvSpPr>
               <p:cNvPr id="11" name="Text 9"/>
@@ -14279,65 +14237,31 @@
                     </a:solidFill>
                   </a:defRPr>
                 </a:pPr>
-                <mc:AlternateContent>
-                  <mc:Choice Requires="a14">
-                    <a14:m>
-                      <m:oMathPara xmlns:m="http://schemas.openxmlformats.org/officeDocument/2006/math">
-                        <m:oMath>
-                          <m:f>
-                            <m:fPr>
-                              <m:ctrlPr>
-                                <a:rPr>
-                                  <a:latin typeface="Cambria Math" panose="02040503050406030204" pitchFamily="18" charset="0"/>
-                                </a:rPr>
-                              </m:ctrlPr>
-                            </m:fPr>
-                            <m:num>
-                              <m:r>
-                                <a:rPr>
-                                  <a:latin typeface="Cambria Math" panose="02040503050406030204" pitchFamily="18" charset="0"/>
-                                </a:rPr>
-                                <m:t>𝑑𝑦</m:t>
-                              </m:r>
-                            </m:num>
-                            <m:den>
-                              <m:r>
-                                <a:rPr>
-                                  <a:latin typeface="Cambria Math" panose="02040503050406030204" pitchFamily="18" charset="0"/>
-                                </a:rPr>
-                                <m:t>ℎ</m:t>
-                              </m:r>
-                              <m:r>
-                                <a:rPr>
-                                  <a:latin typeface="Cambria Math" panose="02040503050406030204" pitchFamily="18" charset="0"/>
-                                </a:rPr>
-                                <m:t>(</m:t>
-                              </m:r>
-                              <m:r>
-                                <a:rPr>
-                                  <a:latin typeface="Cambria Math" panose="02040503050406030204" pitchFamily="18" charset="0"/>
-                                </a:rPr>
-                                <m:t>𝑦</m:t>
-                              </m:r>
-                              <m:r>
-                                <a:rPr>
-                                  <a:latin typeface="Cambria Math" panose="02040503050406030204" pitchFamily="18" charset="0"/>
-                                </a:rPr>
-                                <m:t>)</m:t>
-                              </m:r>
-                            </m:den>
-                          </m:f>
+                <a14:m>
+                  <m:oMathPara xmlns:m="http://schemas.openxmlformats.org/officeDocument/2006/math">
+                    <m:oMath>
+                      <m:f>
+                        <m:fPr>
+                          <m:ctrlPr>
+                            <a:rPr>
+                              <a:latin typeface="Cambria Math" panose="02040503050406030204" pitchFamily="18" charset="0"/>
+                            </a:rPr>
+                          </m:ctrlPr>
+                        </m:fPr>
+                        <m:num>
                           <m:r>
                             <a:rPr>
                               <a:latin typeface="Cambria Math" panose="02040503050406030204" pitchFamily="18" charset="0"/>
                             </a:rPr>
-                            <m:t>=</m:t>
+                            <m:t>𝑑𝑦</m:t>
                           </m:r>
+                        </m:num>
+                        <m:den>
                           <m:r>
                             <a:rPr>
                               <a:latin typeface="Cambria Math" panose="02040503050406030204" pitchFamily="18" charset="0"/>
                             </a:rPr>
-                            <m:t>𝑔</m:t>
+                            <m:t>ℎ</m:t>
                           </m:r>
                           <m:r>
                             <a:rPr>
@@ -14349,7 +14273,7 @@
                             <a:rPr>
                               <a:latin typeface="Cambria Math" panose="02040503050406030204" pitchFamily="18" charset="0"/>
                             </a:rPr>
-                            <m:t>𝑥</m:t>
+                            <m:t>𝑦</m:t>
                           </m:r>
                           <m:r>
                             <a:rPr>
@@ -14357,33 +14281,53 @@
                             </a:rPr>
                             <m:t>)</m:t>
                           </m:r>
-                          <m:r>
-                            <a:rPr>
-                              <a:latin typeface="Cambria Math" panose="02040503050406030204" pitchFamily="18" charset="0"/>
-                            </a:rPr>
-                            <m:t>𝑑𝑥</m:t>
-                          </m:r>
-                        </m:oMath>
-                      </m:oMathPara>
-                    </a14:m>
-                  </mc:Choice>
-                  <mc:Fallback xmlns="">
-                    <a:r>
-                      <a:rPr lang="es-MX" sz="2600">
-                        <a:solidFill>
-                          <a:srgbClr val="0E7490"/>
-                        </a:solidFill>
-                      </a:rPr>
-                      <a:t>\frac{dy}{h(y)} = g(x)\,dx</a:t>
-                    </a:r>
-                  </mc:Fallback>
-                </mc:AlternateContent>
+                        </m:den>
+                      </m:f>
+                      <m:r>
+                        <a:rPr>
+                          <a:latin typeface="Cambria Math" panose="02040503050406030204" pitchFamily="18" charset="0"/>
+                        </a:rPr>
+                        <m:t>=</m:t>
+                      </m:r>
+                      <m:r>
+                        <a:rPr>
+                          <a:latin typeface="Cambria Math" panose="02040503050406030204" pitchFamily="18" charset="0"/>
+                        </a:rPr>
+                        <m:t>𝑔</m:t>
+                      </m:r>
+                      <m:r>
+                        <a:rPr>
+                          <a:latin typeface="Cambria Math" panose="02040503050406030204" pitchFamily="18" charset="0"/>
+                        </a:rPr>
+                        <m:t>(</m:t>
+                      </m:r>
+                      <m:r>
+                        <a:rPr>
+                          <a:latin typeface="Cambria Math" panose="02040503050406030204" pitchFamily="18" charset="0"/>
+                        </a:rPr>
+                        <m:t>𝑥</m:t>
+                      </m:r>
+                      <m:r>
+                        <a:rPr>
+                          <a:latin typeface="Cambria Math" panose="02040503050406030204" pitchFamily="18" charset="0"/>
+                        </a:rPr>
+                        <m:t>)</m:t>
+                      </m:r>
+                      <m:r>
+                        <a:rPr>
+                          <a:latin typeface="Cambria Math" panose="02040503050406030204" pitchFamily="18" charset="0"/>
+                        </a:rPr>
+                        <m:t>𝑑𝑥</m:t>
+                      </m:r>
+                    </m:oMath>
+                  </m:oMathPara>
+                </a14:m>
                 <a:endParaRPr lang="en-US" sz="2600" dirty="0"/>
               </a:p>
             </p:txBody>
           </p:sp>
         </mc:Choice>
-        <mc:Fallback>
+        <mc:Fallback xmlns="">
           <p:sp>
             <p:nvSpPr>
               <p:cNvPr id="11" name="Text 9"/>
@@ -14572,7 +14516,7 @@
             </p:nvSpPr>
             <p:spPr>
               <a:xfrm>
-                <a:off x="777240" y="5120640"/>
+                <a:off x="777240" y="4896352"/>
                 <a:ext cx="4892040" cy="1051560"/>
               </a:xfrm>
               <a:prstGeom prst="rect">
@@ -14599,80 +14543,66 @@
                     </a:solidFill>
                   </a:defRPr>
                 </a:pPr>
-                <mc:AlternateContent>
-                  <mc:Choice Requires="a14">
-                    <a14:m>
-                      <m:oMath xmlns:m="http://schemas.openxmlformats.org/officeDocument/2006/math">
-                        <m:f>
-                          <m:fPr>
-                            <m:ctrlPr>
-                              <a:rPr>
-                                <a:latin typeface="Cambria Math" panose="02040503050406030204" pitchFamily="18" charset="0"/>
-                              </a:rPr>
-                            </m:ctrlPr>
-                          </m:fPr>
-                          <m:num>
-                            <m:r>
-                              <a:rPr>
-                                <a:latin typeface="Cambria Math" panose="02040503050406030204" pitchFamily="18" charset="0"/>
-                              </a:rPr>
-                              <m:t>𝑑𝑦</m:t>
-                            </m:r>
-                          </m:num>
-                          <m:den>
-                            <m:r>
-                              <a:rPr>
-                                <a:latin typeface="Cambria Math" panose="02040503050406030204" pitchFamily="18" charset="0"/>
-                              </a:rPr>
-                              <m:t>𝑑𝑥</m:t>
-                            </m:r>
-                          </m:den>
-                        </m:f>
+                <a14:m>
+                  <m:oMath xmlns:m="http://schemas.openxmlformats.org/officeDocument/2006/math">
+                    <m:f>
+                      <m:fPr>
+                        <m:ctrlPr>
+                          <a:rPr>
+                            <a:latin typeface="Cambria Math" panose="02040503050406030204" pitchFamily="18" charset="0"/>
+                          </a:rPr>
+                        </m:ctrlPr>
+                      </m:fPr>
+                      <m:num>
                         <m:r>
                           <a:rPr>
                             <a:latin typeface="Cambria Math" panose="02040503050406030204" pitchFamily="18" charset="0"/>
                           </a:rPr>
-                          <m:t>=−</m:t>
+                          <m:t>𝑑𝑦</m:t>
                         </m:r>
-                        <m:f>
-                          <m:fPr>
-                            <m:ctrlPr>
-                              <a:rPr>
-                                <a:latin typeface="Cambria Math" panose="02040503050406030204" pitchFamily="18" charset="0"/>
-                              </a:rPr>
-                            </m:ctrlPr>
-                          </m:fPr>
-                          <m:num>
-                            <m:r>
-                              <a:rPr>
-                                <a:latin typeface="Cambria Math" panose="02040503050406030204" pitchFamily="18" charset="0"/>
-                              </a:rPr>
-                              <m:t>𝑥</m:t>
-                            </m:r>
-                          </m:num>
-                          <m:den>
-                            <m:r>
-                              <a:rPr>
-                                <a:latin typeface="Cambria Math" panose="02040503050406030204" pitchFamily="18" charset="0"/>
-                              </a:rPr>
-                              <m:t>𝑦</m:t>
-                            </m:r>
-                          </m:den>
-                        </m:f>
-                      </m:oMath>
-                    </a14:m>
-                  </mc:Choice>
-                  <mc:Fallback xmlns="">
-                    <a:r>
-                      <a:rPr lang="es-MX" sz="1250">
-                        <a:solidFill>
-                          <a:srgbClr val="065F46"/>
-                        </a:solidFill>
+                      </m:num>
+                      <m:den>
+                        <m:r>
+                          <a:rPr>
+                            <a:latin typeface="Cambria Math" panose="02040503050406030204" pitchFamily="18" charset="0"/>
+                          </a:rPr>
+                          <m:t>𝑑𝑥</m:t>
+                        </m:r>
+                      </m:den>
+                    </m:f>
+                    <m:r>
+                      <a:rPr>
+                        <a:latin typeface="Cambria Math" panose="02040503050406030204" pitchFamily="18" charset="0"/>
                       </a:rPr>
-                      <a:t>\frac{dy}{dx} = -\frac{x}{y}</a:t>
-                    </a:r>
-                  </mc:Fallback>
-                </mc:AlternateContent>
+                      <m:t>=−</m:t>
+                    </m:r>
+                    <m:f>
+                      <m:fPr>
+                        <m:ctrlPr>
+                          <a:rPr>
+                            <a:latin typeface="Cambria Math" panose="02040503050406030204" pitchFamily="18" charset="0"/>
+                          </a:rPr>
+                        </m:ctrlPr>
+                      </m:fPr>
+                      <m:num>
+                        <m:r>
+                          <a:rPr>
+                            <a:latin typeface="Cambria Math" panose="02040503050406030204" pitchFamily="18" charset="0"/>
+                          </a:rPr>
+                          <m:t>𝑥</m:t>
+                        </m:r>
+                      </m:num>
+                      <m:den>
+                        <m:r>
+                          <a:rPr>
+                            <a:latin typeface="Cambria Math" panose="02040503050406030204" pitchFamily="18" charset="0"/>
+                          </a:rPr>
+                          <m:t>𝑦</m:t>
+                        </m:r>
+                      </m:den>
+                    </m:f>
+                  </m:oMath>
+                </a14:m>
                 <a:r>
                   <a:rPr lang="en-US" sz="1250" dirty="0">
                     <a:solidFill>
@@ -14684,109 +14614,95 @@
                   </a:rPr>
                   <a:t>   →   </a:t>
                 </a:r>
-                <mc:AlternateContent>
-                  <mc:Choice Requires="a14">
-                    <a14:m>
-                      <m:oMath xmlns:m="http://schemas.openxmlformats.org/officeDocument/2006/math">
+                <a14:m>
+                  <m:oMath xmlns:m="http://schemas.openxmlformats.org/officeDocument/2006/math">
+                    <m:r>
+                      <a:rPr>
+                        <a:latin typeface="Cambria Math" panose="02040503050406030204" pitchFamily="18" charset="0"/>
+                      </a:rPr>
+                      <m:t>𝑔</m:t>
+                    </m:r>
+                    <m:r>
+                      <a:rPr>
+                        <a:latin typeface="Cambria Math" panose="02040503050406030204" pitchFamily="18" charset="0"/>
+                      </a:rPr>
+                      <m:t>(</m:t>
+                    </m:r>
+                    <m:r>
+                      <a:rPr>
+                        <a:latin typeface="Cambria Math" panose="02040503050406030204" pitchFamily="18" charset="0"/>
+                      </a:rPr>
+                      <m:t>𝑥</m:t>
+                    </m:r>
+                    <m:r>
+                      <a:rPr>
+                        <a:latin typeface="Cambria Math" panose="02040503050406030204" pitchFamily="18" charset="0"/>
+                      </a:rPr>
+                      <m:t>)=−</m:t>
+                    </m:r>
+                    <m:r>
+                      <a:rPr>
+                        <a:latin typeface="Cambria Math" panose="02040503050406030204" pitchFamily="18" charset="0"/>
+                      </a:rPr>
+                      <m:t>𝑥</m:t>
+                    </m:r>
+                    <m:r>
+                      <a:rPr>
+                        <a:latin typeface="Cambria Math" panose="02040503050406030204" pitchFamily="18" charset="0"/>
+                      </a:rPr>
+                      <m:t>, </m:t>
+                    </m:r>
+                    <m:r>
+                      <a:rPr>
+                        <a:latin typeface="Cambria Math" panose="02040503050406030204" pitchFamily="18" charset="0"/>
+                      </a:rPr>
+                      <m:t>ℎ</m:t>
+                    </m:r>
+                    <m:r>
+                      <a:rPr>
+                        <a:latin typeface="Cambria Math" panose="02040503050406030204" pitchFamily="18" charset="0"/>
+                      </a:rPr>
+                      <m:t>(</m:t>
+                    </m:r>
+                    <m:r>
+                      <a:rPr>
+                        <a:latin typeface="Cambria Math" panose="02040503050406030204" pitchFamily="18" charset="0"/>
+                      </a:rPr>
+                      <m:t>𝑦</m:t>
+                    </m:r>
+                    <m:r>
+                      <a:rPr>
+                        <a:latin typeface="Cambria Math" panose="02040503050406030204" pitchFamily="18" charset="0"/>
+                      </a:rPr>
+                      <m:t>)=</m:t>
+                    </m:r>
+                    <m:f>
+                      <m:fPr>
+                        <m:ctrlPr>
+                          <a:rPr>
+                            <a:latin typeface="Cambria Math" panose="02040503050406030204" pitchFamily="18" charset="0"/>
+                          </a:rPr>
+                        </m:ctrlPr>
+                      </m:fPr>
+                      <m:num>
                         <m:r>
                           <a:rPr>
                             <a:latin typeface="Cambria Math" panose="02040503050406030204" pitchFamily="18" charset="0"/>
                           </a:rPr>
-                          <m:t>𝑔</m:t>
+                          <m:t>1</m:t>
                         </m:r>
-                        <m:r>
-                          <a:rPr>
-                            <a:latin typeface="Cambria Math" panose="02040503050406030204" pitchFamily="18" charset="0"/>
-                          </a:rPr>
-                          <m:t>(</m:t>
-                        </m:r>
-                        <m:r>
-                          <a:rPr>
-                            <a:latin typeface="Cambria Math" panose="02040503050406030204" pitchFamily="18" charset="0"/>
-                          </a:rPr>
-                          <m:t>𝑥</m:t>
-                        </m:r>
-                        <m:r>
-                          <a:rPr>
-                            <a:latin typeface="Cambria Math" panose="02040503050406030204" pitchFamily="18" charset="0"/>
-                          </a:rPr>
-                          <m:t>)=−</m:t>
-                        </m:r>
-                        <m:r>
-                          <a:rPr>
-                            <a:latin typeface="Cambria Math" panose="02040503050406030204" pitchFamily="18" charset="0"/>
-                          </a:rPr>
-                          <m:t>𝑥</m:t>
-                        </m:r>
-                        <m:r>
-                          <a:rPr>
-                            <a:latin typeface="Cambria Math" panose="02040503050406030204" pitchFamily="18" charset="0"/>
-                          </a:rPr>
-                          <m:t>, </m:t>
-                        </m:r>
-                        <m:r>
-                          <a:rPr>
-                            <a:latin typeface="Cambria Math" panose="02040503050406030204" pitchFamily="18" charset="0"/>
-                          </a:rPr>
-                          <m:t>ℎ</m:t>
-                        </m:r>
-                        <m:r>
-                          <a:rPr>
-                            <a:latin typeface="Cambria Math" panose="02040503050406030204" pitchFamily="18" charset="0"/>
-                          </a:rPr>
-                          <m:t>(</m:t>
-                        </m:r>
+                      </m:num>
+                      <m:den>
                         <m:r>
                           <a:rPr>
                             <a:latin typeface="Cambria Math" panose="02040503050406030204" pitchFamily="18" charset="0"/>
                           </a:rPr>
                           <m:t>𝑦</m:t>
                         </m:r>
-                        <m:r>
-                          <a:rPr>
-                            <a:latin typeface="Cambria Math" panose="02040503050406030204" pitchFamily="18" charset="0"/>
-                          </a:rPr>
-                          <m:t>)=</m:t>
-                        </m:r>
-                        <m:f>
-                          <m:fPr>
-                            <m:ctrlPr>
-                              <a:rPr>
-                                <a:latin typeface="Cambria Math" panose="02040503050406030204" pitchFamily="18" charset="0"/>
-                              </a:rPr>
-                            </m:ctrlPr>
-                          </m:fPr>
-                          <m:num>
-                            <m:r>
-                              <a:rPr>
-                                <a:latin typeface="Cambria Math" panose="02040503050406030204" pitchFamily="18" charset="0"/>
-                              </a:rPr>
-                              <m:t>1</m:t>
-                            </m:r>
-                          </m:num>
-                          <m:den>
-                            <m:r>
-                              <a:rPr>
-                                <a:latin typeface="Cambria Math" panose="02040503050406030204" pitchFamily="18" charset="0"/>
-                              </a:rPr>
-                              <m:t>𝑦</m:t>
-                            </m:r>
-                          </m:den>
-                        </m:f>
-                      </m:oMath>
-                    </a14:m>
-                  </mc:Choice>
-                  <mc:Fallback xmlns="">
-                    <a:r>
-                      <a:rPr lang="es-MX" sz="1250">
-                        <a:solidFill>
-                          <a:srgbClr val="065F46"/>
-                        </a:solidFill>
-                      </a:rPr>
-                      <a:t>g(x)=-x,\ h(y)=\frac{1}{y}</a:t>
-                    </a:r>
-                  </mc:Fallback>
-                </mc:AlternateContent>
+                      </m:den>
+                    </m:f>
+                  </m:oMath>
+                </a14:m>
                 <a:endParaRPr lang="en-US" sz="1250" dirty="0"/>
               </a:p>
               <a:p>
@@ -14804,33 +14720,54 @@
                     </a:solidFill>
                   </a:defRPr>
                 </a:pPr>
-                <mc:AlternateContent>
-                  <mc:Choice Requires="a14">
-                    <a14:m>
-                      <m:oMath xmlns:m="http://schemas.openxmlformats.org/officeDocument/2006/math">
+                <a14:m>
+                  <m:oMath xmlns:m="http://schemas.openxmlformats.org/officeDocument/2006/math">
+                    <m:r>
+                      <a:rPr>
+                        <a:latin typeface="Cambria Math" panose="02040503050406030204" pitchFamily="18" charset="0"/>
+                      </a:rPr>
+                      <m:t>𝑑𝑦</m:t>
+                    </m:r>
+                    <m:r>
+                      <a:rPr>
+                        <a:latin typeface="Cambria Math" panose="02040503050406030204" pitchFamily="18" charset="0"/>
+                      </a:rPr>
+                      <m:t>/</m:t>
+                    </m:r>
+                    <m:r>
+                      <a:rPr>
+                        <a:latin typeface="Cambria Math" panose="02040503050406030204" pitchFamily="18" charset="0"/>
+                      </a:rPr>
+                      <m:t>𝑑𝑥</m:t>
+                    </m:r>
+                    <m:r>
+                      <a:rPr>
+                        <a:latin typeface="Cambria Math" panose="02040503050406030204" pitchFamily="18" charset="0"/>
+                      </a:rPr>
+                      <m:t>=</m:t>
+                    </m:r>
+                    <m:sSup>
+                      <m:sSupPr>
+                        <m:ctrlPr>
+                          <a:rPr>
+                            <a:latin typeface="Cambria Math" panose="02040503050406030204" pitchFamily="18" charset="0"/>
+                          </a:rPr>
+                        </m:ctrlPr>
+                      </m:sSupPr>
+                      <m:e>
                         <m:r>
                           <a:rPr>
                             <a:latin typeface="Cambria Math" panose="02040503050406030204" pitchFamily="18" charset="0"/>
                           </a:rPr>
-                          <m:t>𝑑𝑦</m:t>
+                          <m:t>𝑒</m:t>
                         </m:r>
+                      </m:e>
+                      <m:sup>
                         <m:r>
                           <a:rPr>
                             <a:latin typeface="Cambria Math" panose="02040503050406030204" pitchFamily="18" charset="0"/>
                           </a:rPr>
-                          <m:t>/</m:t>
-                        </m:r>
-                        <m:r>
-                          <a:rPr>
-                            <a:latin typeface="Cambria Math" panose="02040503050406030204" pitchFamily="18" charset="0"/>
-                          </a:rPr>
-                          <m:t>𝑑𝑥</m:t>
-                        </m:r>
-                        <m:r>
-                          <a:rPr>
-                            <a:latin typeface="Cambria Math" panose="02040503050406030204" pitchFamily="18" charset="0"/>
-                          </a:rPr>
-                          <m:t>=</m:t>
+                          <m:t>−</m:t>
                         </m:r>
                         <m:sSup>
                           <m:sSupPr>
@@ -14845,7 +14782,7 @@
                               <a:rPr>
                                 <a:latin typeface="Cambria Math" panose="02040503050406030204" pitchFamily="18" charset="0"/>
                               </a:rPr>
-                              <m:t>𝑒</m:t>
+                              <m:t>𝑥</m:t>
                             </m:r>
                           </m:e>
                           <m:sup>
@@ -14853,49 +14790,14 @@
                               <a:rPr>
                                 <a:latin typeface="Cambria Math" panose="02040503050406030204" pitchFamily="18" charset="0"/>
                               </a:rPr>
-                              <m:t>−</m:t>
+                              <m:t>2</m:t>
                             </m:r>
-                            <m:sSup>
-                              <m:sSupPr>
-                                <m:ctrlPr>
-                                  <a:rPr>
-                                    <a:latin typeface="Cambria Math" panose="02040503050406030204" pitchFamily="18" charset="0"/>
-                                  </a:rPr>
-                                </m:ctrlPr>
-                              </m:sSupPr>
-                              <m:e>
-                                <m:r>
-                                  <a:rPr>
-                                    <a:latin typeface="Cambria Math" panose="02040503050406030204" pitchFamily="18" charset="0"/>
-                                  </a:rPr>
-                                  <m:t>𝑥</m:t>
-                                </m:r>
-                              </m:e>
-                              <m:sup>
-                                <m:r>
-                                  <a:rPr>
-                                    <a:latin typeface="Cambria Math" panose="02040503050406030204" pitchFamily="18" charset="0"/>
-                                  </a:rPr>
-                                  <m:t>2</m:t>
-                                </m:r>
-                              </m:sup>
-                            </m:sSup>
                           </m:sup>
                         </m:sSup>
-                      </m:oMath>
-                    </a14:m>
-                  </mc:Choice>
-                  <mc:Fallback xmlns="">
-                    <a:r>
-                      <a:rPr lang="es-MX" sz="1250">
-                        <a:solidFill>
-                          <a:srgbClr val="065F46"/>
-                        </a:solidFill>
-                      </a:rPr>
-                      <a:t>dy/dx = e^{-x^2}</a:t>
-                    </a:r>
-                  </mc:Fallback>
-                </mc:AlternateContent>
+                      </m:sup>
+                    </m:sSup>
+                  </m:oMath>
+                </a14:m>
                 <a:r>
                   <a:rPr lang="en-US" sz="1250" dirty="0">
                     <a:solidFill>
@@ -14907,33 +14809,54 @@
                   </a:rPr>
                   <a:t>   →   </a:t>
                 </a:r>
-                <mc:AlternateContent>
-                  <mc:Choice Requires="a14">
-                    <a14:m>
-                      <m:oMath xmlns:m="http://schemas.openxmlformats.org/officeDocument/2006/math">
+                <a14:m>
+                  <m:oMath xmlns:m="http://schemas.openxmlformats.org/officeDocument/2006/math">
+                    <m:r>
+                      <a:rPr>
+                        <a:latin typeface="Cambria Math" panose="02040503050406030204" pitchFamily="18" charset="0"/>
+                      </a:rPr>
+                      <m:t>𝑔</m:t>
+                    </m:r>
+                    <m:r>
+                      <a:rPr>
+                        <a:latin typeface="Cambria Math" panose="02040503050406030204" pitchFamily="18" charset="0"/>
+                      </a:rPr>
+                      <m:t>(</m:t>
+                    </m:r>
+                    <m:r>
+                      <a:rPr>
+                        <a:latin typeface="Cambria Math" panose="02040503050406030204" pitchFamily="18" charset="0"/>
+                      </a:rPr>
+                      <m:t>𝑥</m:t>
+                    </m:r>
+                    <m:r>
+                      <a:rPr>
+                        <a:latin typeface="Cambria Math" panose="02040503050406030204" pitchFamily="18" charset="0"/>
+                      </a:rPr>
+                      <m:t>)=</m:t>
+                    </m:r>
+                    <m:sSup>
+                      <m:sSupPr>
+                        <m:ctrlPr>
+                          <a:rPr>
+                            <a:latin typeface="Cambria Math" panose="02040503050406030204" pitchFamily="18" charset="0"/>
+                          </a:rPr>
+                        </m:ctrlPr>
+                      </m:sSupPr>
+                      <m:e>
                         <m:r>
                           <a:rPr>
                             <a:latin typeface="Cambria Math" panose="02040503050406030204" pitchFamily="18" charset="0"/>
                           </a:rPr>
-                          <m:t>𝑔</m:t>
+                          <m:t>𝑒</m:t>
                         </m:r>
+                      </m:e>
+                      <m:sup>
                         <m:r>
                           <a:rPr>
                             <a:latin typeface="Cambria Math" panose="02040503050406030204" pitchFamily="18" charset="0"/>
                           </a:rPr>
-                          <m:t>(</m:t>
-                        </m:r>
-                        <m:r>
-                          <a:rPr>
-                            <a:latin typeface="Cambria Math" panose="02040503050406030204" pitchFamily="18" charset="0"/>
-                          </a:rPr>
-                          <m:t>𝑥</m:t>
-                        </m:r>
-                        <m:r>
-                          <a:rPr>
-                            <a:latin typeface="Cambria Math" panose="02040503050406030204" pitchFamily="18" charset="0"/>
-                          </a:rPr>
-                          <m:t>)=</m:t>
+                          <m:t>−</m:t>
                         </m:r>
                         <m:sSup>
                           <m:sSupPr>
@@ -14948,7 +14871,7 @@
                               <a:rPr>
                                 <a:latin typeface="Cambria Math" panose="02040503050406030204" pitchFamily="18" charset="0"/>
                               </a:rPr>
-                              <m:t>𝑒</m:t>
+                              <m:t>𝑥</m:t>
                             </m:r>
                           </m:e>
                           <m:sup>
@@ -14956,79 +14879,44 @@
                               <a:rPr>
                                 <a:latin typeface="Cambria Math" panose="02040503050406030204" pitchFamily="18" charset="0"/>
                               </a:rPr>
-                              <m:t>−</m:t>
+                              <m:t>2</m:t>
                             </m:r>
-                            <m:sSup>
-                              <m:sSupPr>
-                                <m:ctrlPr>
-                                  <a:rPr>
-                                    <a:latin typeface="Cambria Math" panose="02040503050406030204" pitchFamily="18" charset="0"/>
-                                  </a:rPr>
-                                </m:ctrlPr>
-                              </m:sSupPr>
-                              <m:e>
-                                <m:r>
-                                  <a:rPr>
-                                    <a:latin typeface="Cambria Math" panose="02040503050406030204" pitchFamily="18" charset="0"/>
-                                  </a:rPr>
-                                  <m:t>𝑥</m:t>
-                                </m:r>
-                              </m:e>
-                              <m:sup>
-                                <m:r>
-                                  <a:rPr>
-                                    <a:latin typeface="Cambria Math" panose="02040503050406030204" pitchFamily="18" charset="0"/>
-                                  </a:rPr>
-                                  <m:t>2</m:t>
-                                </m:r>
-                              </m:sup>
-                            </m:sSup>
                           </m:sup>
                         </m:sSup>
-                        <m:r>
-                          <a:rPr>
-                            <a:latin typeface="Cambria Math" panose="02040503050406030204" pitchFamily="18" charset="0"/>
-                          </a:rPr>
-                          <m:t>, </m:t>
-                        </m:r>
-                        <m:r>
-                          <a:rPr>
-                            <a:latin typeface="Cambria Math" panose="02040503050406030204" pitchFamily="18" charset="0"/>
-                          </a:rPr>
-                          <m:t>ℎ</m:t>
-                        </m:r>
-                        <m:r>
-                          <a:rPr>
-                            <a:latin typeface="Cambria Math" panose="02040503050406030204" pitchFamily="18" charset="0"/>
-                          </a:rPr>
-                          <m:t>(</m:t>
-                        </m:r>
-                        <m:r>
-                          <a:rPr>
-                            <a:latin typeface="Cambria Math" panose="02040503050406030204" pitchFamily="18" charset="0"/>
-                          </a:rPr>
-                          <m:t>𝑦</m:t>
-                        </m:r>
-                        <m:r>
-                          <a:rPr>
-                            <a:latin typeface="Cambria Math" panose="02040503050406030204" pitchFamily="18" charset="0"/>
-                          </a:rPr>
-                          <m:t>)=1</m:t>
-                        </m:r>
-                      </m:oMath>
-                    </a14:m>
-                  </mc:Choice>
-                  <mc:Fallback xmlns="">
-                    <a:r>
-                      <a:rPr lang="es-MX" sz="1250">
-                        <a:solidFill>
-                          <a:srgbClr val="065F46"/>
-                        </a:solidFill>
+                      </m:sup>
+                    </m:sSup>
+                    <m:r>
+                      <a:rPr>
+                        <a:latin typeface="Cambria Math" panose="02040503050406030204" pitchFamily="18" charset="0"/>
                       </a:rPr>
-                      <a:t>g(x)=e^{-x^2},\ h(y)=1</a:t>
-                    </a:r>
-                  </mc:Fallback>
-                </mc:AlternateContent>
+                      <m:t>, </m:t>
+                    </m:r>
+                    <m:r>
+                      <a:rPr>
+                        <a:latin typeface="Cambria Math" panose="02040503050406030204" pitchFamily="18" charset="0"/>
+                      </a:rPr>
+                      <m:t>ℎ</m:t>
+                    </m:r>
+                    <m:r>
+                      <a:rPr>
+                        <a:latin typeface="Cambria Math" panose="02040503050406030204" pitchFamily="18" charset="0"/>
+                      </a:rPr>
+                      <m:t>(</m:t>
+                    </m:r>
+                    <m:r>
+                      <a:rPr>
+                        <a:latin typeface="Cambria Math" panose="02040503050406030204" pitchFamily="18" charset="0"/>
+                      </a:rPr>
+                      <m:t>𝑦</m:t>
+                    </m:r>
+                    <m:r>
+                      <a:rPr>
+                        <a:latin typeface="Cambria Math" panose="02040503050406030204" pitchFamily="18" charset="0"/>
+                      </a:rPr>
+                      <m:t>)=1</m:t>
+                    </m:r>
+                  </m:oMath>
+                </a14:m>
                 <a:endParaRPr lang="en-US" sz="1250" dirty="0"/>
               </a:p>
               <a:p>
@@ -15046,66 +14934,52 @@
                     </a:solidFill>
                   </a:defRPr>
                 </a:pPr>
-                <mc:AlternateContent>
-                  <mc:Choice Requires="a14">
-                    <a14:m>
-                      <m:oMath xmlns:m="http://schemas.openxmlformats.org/officeDocument/2006/math">
-                        <m:r>
-                          <a:rPr>
-                            <a:latin typeface="Cambria Math" panose="02040503050406030204" pitchFamily="18" charset="0"/>
-                          </a:rPr>
-                          <m:t>(1+</m:t>
-                        </m:r>
-                        <m:r>
-                          <a:rPr>
-                            <a:latin typeface="Cambria Math" panose="02040503050406030204" pitchFamily="18" charset="0"/>
-                          </a:rPr>
-                          <m:t>𝑥</m:t>
-                        </m:r>
-                        <m:r>
-                          <a:rPr>
-                            <a:latin typeface="Cambria Math" panose="02040503050406030204" pitchFamily="18" charset="0"/>
-                          </a:rPr>
-                          <m:t>)</m:t>
-                        </m:r>
-                        <m:r>
-                          <a:rPr>
-                            <a:latin typeface="Cambria Math" panose="02040503050406030204" pitchFamily="18" charset="0"/>
-                          </a:rPr>
-                          <m:t>𝑑𝑦</m:t>
-                        </m:r>
-                        <m:r>
-                          <a:rPr>
-                            <a:latin typeface="Cambria Math" panose="02040503050406030204" pitchFamily="18" charset="0"/>
-                          </a:rPr>
-                          <m:t>−</m:t>
-                        </m:r>
-                        <m:r>
-                          <a:rPr>
-                            <a:latin typeface="Cambria Math" panose="02040503050406030204" pitchFamily="18" charset="0"/>
-                          </a:rPr>
-                          <m:t>𝑦𝑑𝑥</m:t>
-                        </m:r>
-                        <m:r>
-                          <a:rPr>
-                            <a:latin typeface="Cambria Math" panose="02040503050406030204" pitchFamily="18" charset="0"/>
-                          </a:rPr>
-                          <m:t>=0</m:t>
-                        </m:r>
-                      </m:oMath>
-                    </a14:m>
-                  </mc:Choice>
-                  <mc:Fallback xmlns="">
-                    <a:r>
-                      <a:rPr lang="es-MX" sz="1250">
-                        <a:solidFill>
-                          <a:srgbClr val="065F46"/>
-                        </a:solidFill>
+                <a14:m>
+                  <m:oMath xmlns:m="http://schemas.openxmlformats.org/officeDocument/2006/math">
+                    <m:r>
+                      <a:rPr>
+                        <a:latin typeface="Cambria Math" panose="02040503050406030204" pitchFamily="18" charset="0"/>
                       </a:rPr>
-                      <a:t>(1+x)\,dy - y\,dx = 0</a:t>
-                    </a:r>
-                  </mc:Fallback>
-                </mc:AlternateContent>
+                      <m:t>(1+</m:t>
+                    </m:r>
+                    <m:r>
+                      <a:rPr>
+                        <a:latin typeface="Cambria Math" panose="02040503050406030204" pitchFamily="18" charset="0"/>
+                      </a:rPr>
+                      <m:t>𝑥</m:t>
+                    </m:r>
+                    <m:r>
+                      <a:rPr>
+                        <a:latin typeface="Cambria Math" panose="02040503050406030204" pitchFamily="18" charset="0"/>
+                      </a:rPr>
+                      <m:t>)</m:t>
+                    </m:r>
+                    <m:r>
+                      <a:rPr>
+                        <a:latin typeface="Cambria Math" panose="02040503050406030204" pitchFamily="18" charset="0"/>
+                      </a:rPr>
+                      <m:t>𝑑𝑦</m:t>
+                    </m:r>
+                    <m:r>
+                      <a:rPr>
+                        <a:latin typeface="Cambria Math" panose="02040503050406030204" pitchFamily="18" charset="0"/>
+                      </a:rPr>
+                      <m:t>−</m:t>
+                    </m:r>
+                    <m:r>
+                      <a:rPr>
+                        <a:latin typeface="Cambria Math" panose="02040503050406030204" pitchFamily="18" charset="0"/>
+                      </a:rPr>
+                      <m:t>𝑦𝑑𝑥</m:t>
+                    </m:r>
+                    <m:r>
+                      <a:rPr>
+                        <a:latin typeface="Cambria Math" panose="02040503050406030204" pitchFamily="18" charset="0"/>
+                      </a:rPr>
+                      <m:t>=0</m:t>
+                    </m:r>
+                  </m:oMath>
+                </a14:m>
                 <a:r>
                   <a:rPr lang="en-US" sz="1250" dirty="0">
                     <a:solidFill>
@@ -15133,7 +15007,7 @@
             </p:nvSpPr>
             <p:spPr>
               <a:xfrm>
-                <a:off x="777240" y="5120640"/>
+                <a:off x="777240" y="4896352"/>
                 <a:ext cx="4892040" cy="1051560"/>
               </a:xfrm>
               <a:prstGeom prst="rect">
@@ -15142,7 +15016,7 @@
               <a:blipFill>
                 <a:blip r:embed="rId6"/>
                 <a:stretch>
-                  <a:fillRect b="-31214"/>
+                  <a:fillRect b="-31792"/>
                 </a:stretch>
               </a:blipFill>
               <a:ln/>
@@ -15301,8 +15175,8 @@
           </a:p>
         </p:txBody>
       </p:sp>
-      <mc:AlternateContent xmlns:mc="http://schemas.openxmlformats.org/markup-compatibility/2006">
-        <mc:Choice xmlns:a14="http://schemas.microsoft.com/office/drawing/2010/main" Requires="a14">
+      <mc:AlternateContent xmlns:mc="http://schemas.openxmlformats.org/markup-compatibility/2006" xmlns:a14="http://schemas.microsoft.com/office/drawing/2010/main">
+        <mc:Choice Requires="a14">
           <p:sp>
             <p:nvSpPr>
               <p:cNvPr id="21" name="Text 19"/>
@@ -15338,66 +15212,52 @@
                     </a:solidFill>
                   </a:defRPr>
                 </a:pPr>
-                <mc:AlternateContent>
-                  <mc:Choice Requires="a14">
-                    <a14:m>
-                      <m:oMath xmlns:m="http://schemas.openxmlformats.org/officeDocument/2006/math">
-                        <m:r>
-                          <a:rPr>
-                            <a:latin typeface="Cambria Math" panose="02040503050406030204" pitchFamily="18" charset="0"/>
-                          </a:rPr>
-                          <m:t>𝑑𝑦</m:t>
-                        </m:r>
-                        <m:r>
-                          <a:rPr>
-                            <a:latin typeface="Cambria Math" panose="02040503050406030204" pitchFamily="18" charset="0"/>
-                          </a:rPr>
-                          <m:t>/</m:t>
-                        </m:r>
-                        <m:r>
-                          <a:rPr>
-                            <a:latin typeface="Cambria Math" panose="02040503050406030204" pitchFamily="18" charset="0"/>
-                          </a:rPr>
-                          <m:t>𝑑𝑥</m:t>
-                        </m:r>
-                        <m:r>
-                          <a:rPr>
-                            <a:latin typeface="Cambria Math" panose="02040503050406030204" pitchFamily="18" charset="0"/>
-                          </a:rPr>
-                          <m:t>=</m:t>
-                        </m:r>
-                        <m:r>
-                          <a:rPr>
-                            <a:latin typeface="Cambria Math" panose="02040503050406030204" pitchFamily="18" charset="0"/>
-                          </a:rPr>
-                          <m:t>𝑥</m:t>
-                        </m:r>
-                        <m:r>
-                          <a:rPr>
-                            <a:latin typeface="Cambria Math" panose="02040503050406030204" pitchFamily="18" charset="0"/>
-                          </a:rPr>
-                          <m:t>+</m:t>
-                        </m:r>
-                        <m:r>
-                          <a:rPr>
-                            <a:latin typeface="Cambria Math" panose="02040503050406030204" pitchFamily="18" charset="0"/>
-                          </a:rPr>
-                          <m:t>𝑦</m:t>
-                        </m:r>
-                      </m:oMath>
-                    </a14:m>
-                  </mc:Choice>
-                  <mc:Fallback xmlns="">
-                    <a:r>
-                      <a:rPr lang="es-MX" sz="1250">
-                        <a:solidFill>
-                          <a:srgbClr val="9F1239"/>
-                        </a:solidFill>
+                <a14:m>
+                  <m:oMath xmlns:m="http://schemas.openxmlformats.org/officeDocument/2006/math">
+                    <m:r>
+                      <a:rPr>
+                        <a:latin typeface="Cambria Math" panose="02040503050406030204" pitchFamily="18" charset="0"/>
                       </a:rPr>
-                      <a:t>dy/dx = x+y</a:t>
-                    </a:r>
-                  </mc:Fallback>
-                </mc:AlternateContent>
+                      <m:t>𝑑𝑦</m:t>
+                    </m:r>
+                    <m:r>
+                      <a:rPr>
+                        <a:latin typeface="Cambria Math" panose="02040503050406030204" pitchFamily="18" charset="0"/>
+                      </a:rPr>
+                      <m:t>/</m:t>
+                    </m:r>
+                    <m:r>
+                      <a:rPr>
+                        <a:latin typeface="Cambria Math" panose="02040503050406030204" pitchFamily="18" charset="0"/>
+                      </a:rPr>
+                      <m:t>𝑑𝑥</m:t>
+                    </m:r>
+                    <m:r>
+                      <a:rPr>
+                        <a:latin typeface="Cambria Math" panose="02040503050406030204" pitchFamily="18" charset="0"/>
+                      </a:rPr>
+                      <m:t>=</m:t>
+                    </m:r>
+                    <m:r>
+                      <a:rPr>
+                        <a:latin typeface="Cambria Math" panose="02040503050406030204" pitchFamily="18" charset="0"/>
+                      </a:rPr>
+                      <m:t>𝑥</m:t>
+                    </m:r>
+                    <m:r>
+                      <a:rPr>
+                        <a:latin typeface="Cambria Math" panose="02040503050406030204" pitchFamily="18" charset="0"/>
+                      </a:rPr>
+                      <m:t>+</m:t>
+                    </m:r>
+                    <m:r>
+                      <a:rPr>
+                        <a:latin typeface="Cambria Math" panose="02040503050406030204" pitchFamily="18" charset="0"/>
+                      </a:rPr>
+                      <m:t>𝑦</m:t>
+                    </m:r>
+                  </m:oMath>
+                </a14:m>
                 <a:r>
                   <a:rPr lang="en-US" sz="1250" dirty="0">
                     <a:solidFill>
@@ -15426,66 +15286,52 @@
                     </a:solidFill>
                   </a:defRPr>
                 </a:pPr>
-                <mc:AlternateContent>
-                  <mc:Choice Requires="a14">
-                    <a14:m>
-                      <m:oMath xmlns:m="http://schemas.openxmlformats.org/officeDocument/2006/math">
-                        <m:r>
-                          <a:rPr>
-                            <a:latin typeface="Cambria Math" panose="02040503050406030204" pitchFamily="18" charset="0"/>
-                          </a:rPr>
-                          <m:t>𝑑𝑦</m:t>
-                        </m:r>
-                        <m:r>
-                          <a:rPr>
-                            <a:latin typeface="Cambria Math" panose="02040503050406030204" pitchFamily="18" charset="0"/>
-                          </a:rPr>
-                          <m:t>/</m:t>
-                        </m:r>
-                        <m:r>
-                          <a:rPr>
-                            <a:latin typeface="Cambria Math" panose="02040503050406030204" pitchFamily="18" charset="0"/>
-                          </a:rPr>
-                          <m:t>𝑑𝑥</m:t>
-                        </m:r>
-                        <m:r>
-                          <a:rPr>
-                            <a:latin typeface="Cambria Math" panose="02040503050406030204" pitchFamily="18" charset="0"/>
-                          </a:rPr>
-                          <m:t>=</m:t>
-                        </m:r>
-                        <m:r>
-                          <a:rPr>
-                            <a:latin typeface="Cambria Math" panose="02040503050406030204" pitchFamily="18" charset="0"/>
-                          </a:rPr>
-                          <m:t>𝑥𝑦</m:t>
-                        </m:r>
-                        <m:r>
-                          <a:rPr>
-                            <a:latin typeface="Cambria Math" panose="02040503050406030204" pitchFamily="18" charset="0"/>
-                          </a:rPr>
-                          <m:t>+</m:t>
-                        </m:r>
-                        <m:r>
-                          <a:rPr>
-                            <a:latin typeface="Cambria Math" panose="02040503050406030204" pitchFamily="18" charset="0"/>
-                          </a:rPr>
-                          <m:t>𝑥</m:t>
-                        </m:r>
-                      </m:oMath>
-                    </a14:m>
-                  </mc:Choice>
-                  <mc:Fallback xmlns="">
-                    <a:r>
-                      <a:rPr lang="es-MX" sz="1250">
-                        <a:solidFill>
-                          <a:srgbClr val="9F1239"/>
-                        </a:solidFill>
+                <a14:m>
+                  <m:oMath xmlns:m="http://schemas.openxmlformats.org/officeDocument/2006/math">
+                    <m:r>
+                      <a:rPr>
+                        <a:latin typeface="Cambria Math" panose="02040503050406030204" pitchFamily="18" charset="0"/>
                       </a:rPr>
-                      <a:t>dy/dx = xy+x</a:t>
-                    </a:r>
-                  </mc:Fallback>
-                </mc:AlternateContent>
+                      <m:t>𝑑𝑦</m:t>
+                    </m:r>
+                    <m:r>
+                      <a:rPr>
+                        <a:latin typeface="Cambria Math" panose="02040503050406030204" pitchFamily="18" charset="0"/>
+                      </a:rPr>
+                      <m:t>/</m:t>
+                    </m:r>
+                    <m:r>
+                      <a:rPr>
+                        <a:latin typeface="Cambria Math" panose="02040503050406030204" pitchFamily="18" charset="0"/>
+                      </a:rPr>
+                      <m:t>𝑑𝑥</m:t>
+                    </m:r>
+                    <m:r>
+                      <a:rPr>
+                        <a:latin typeface="Cambria Math" panose="02040503050406030204" pitchFamily="18" charset="0"/>
+                      </a:rPr>
+                      <m:t>=</m:t>
+                    </m:r>
+                    <m:r>
+                      <a:rPr>
+                        <a:latin typeface="Cambria Math" panose="02040503050406030204" pitchFamily="18" charset="0"/>
+                      </a:rPr>
+                      <m:t>𝑥𝑦</m:t>
+                    </m:r>
+                    <m:r>
+                      <a:rPr>
+                        <a:latin typeface="Cambria Math" panose="02040503050406030204" pitchFamily="18" charset="0"/>
+                      </a:rPr>
+                      <m:t>+</m:t>
+                    </m:r>
+                    <m:r>
+                      <a:rPr>
+                        <a:latin typeface="Cambria Math" panose="02040503050406030204" pitchFamily="18" charset="0"/>
+                      </a:rPr>
+                      <m:t>𝑥</m:t>
+                    </m:r>
+                  </m:oMath>
+                </a14:m>
                 <a:r>
                   <a:rPr lang="en-US" sz="1250" dirty="0">
                     <a:solidFill>
@@ -15497,54 +15343,40 @@
                   </a:rPr>
                   <a:t>   →   ¡cuidado! sí lo es:   </a:t>
                 </a:r>
-                <mc:AlternateContent>
-                  <mc:Choice Requires="a14">
-                    <a14:m>
-                      <m:oMath xmlns:m="http://schemas.openxmlformats.org/officeDocument/2006/math">
-                        <m:r>
-                          <a:rPr>
-                            <a:latin typeface="Cambria Math" panose="02040503050406030204" pitchFamily="18" charset="0"/>
-                          </a:rPr>
-                          <m:t>=</m:t>
-                        </m:r>
-                        <m:r>
-                          <a:rPr>
-                            <a:latin typeface="Cambria Math" panose="02040503050406030204" pitchFamily="18" charset="0"/>
-                          </a:rPr>
-                          <m:t>𝑥</m:t>
-                        </m:r>
-                        <m:r>
-                          <a:rPr>
-                            <a:latin typeface="Cambria Math" panose="02040503050406030204" pitchFamily="18" charset="0"/>
-                          </a:rPr>
-                          <m:t>(</m:t>
-                        </m:r>
-                        <m:r>
-                          <a:rPr>
-                            <a:latin typeface="Cambria Math" panose="02040503050406030204" pitchFamily="18" charset="0"/>
-                          </a:rPr>
-                          <m:t>𝑦</m:t>
-                        </m:r>
-                        <m:r>
-                          <a:rPr>
-                            <a:latin typeface="Cambria Math" panose="02040503050406030204" pitchFamily="18" charset="0"/>
-                          </a:rPr>
-                          <m:t>+1)</m:t>
-                        </m:r>
-                      </m:oMath>
-                    </a14:m>
-                  </mc:Choice>
-                  <mc:Fallback xmlns="">
-                    <a:r>
-                      <a:rPr lang="es-MX" sz="1250">
-                        <a:solidFill>
-                          <a:srgbClr val="9F1239"/>
-                        </a:solidFill>
+                <a14:m>
+                  <m:oMath xmlns:m="http://schemas.openxmlformats.org/officeDocument/2006/math">
+                    <m:r>
+                      <a:rPr>
+                        <a:latin typeface="Cambria Math" panose="02040503050406030204" pitchFamily="18" charset="0"/>
                       </a:rPr>
-                      <a:t>=x(y+1)</a:t>
-                    </a:r>
-                  </mc:Fallback>
-                </mc:AlternateContent>
+                      <m:t>=</m:t>
+                    </m:r>
+                    <m:r>
+                      <a:rPr>
+                        <a:latin typeface="Cambria Math" panose="02040503050406030204" pitchFamily="18" charset="0"/>
+                      </a:rPr>
+                      <m:t>𝑥</m:t>
+                    </m:r>
+                    <m:r>
+                      <a:rPr>
+                        <a:latin typeface="Cambria Math" panose="02040503050406030204" pitchFamily="18" charset="0"/>
+                      </a:rPr>
+                      <m:t>(</m:t>
+                    </m:r>
+                    <m:r>
+                      <a:rPr>
+                        <a:latin typeface="Cambria Math" panose="02040503050406030204" pitchFamily="18" charset="0"/>
+                      </a:rPr>
+                      <m:t>𝑦</m:t>
+                    </m:r>
+                    <m:r>
+                      <a:rPr>
+                        <a:latin typeface="Cambria Math" panose="02040503050406030204" pitchFamily="18" charset="0"/>
+                      </a:rPr>
+                      <m:t>+1)</m:t>
+                    </m:r>
+                  </m:oMath>
+                </a14:m>
                 <a:endParaRPr lang="en-US" sz="1250" dirty="0"/>
               </a:p>
               <a:p>
@@ -15562,87 +15394,73 @@
                     </a:solidFill>
                   </a:defRPr>
                 </a:pPr>
-                <mc:AlternateContent>
-                  <mc:Choice Requires="a14">
-                    <a14:m>
-                      <m:oMath xmlns:m="http://schemas.openxmlformats.org/officeDocument/2006/math">
-                        <m:r>
-                          <a:rPr>
-                            <a:latin typeface="Cambria Math" panose="02040503050406030204" pitchFamily="18" charset="0"/>
-                          </a:rPr>
-                          <m:t>𝑑𝑦</m:t>
-                        </m:r>
-                        <m:r>
-                          <a:rPr>
-                            <a:latin typeface="Cambria Math" panose="02040503050406030204" pitchFamily="18" charset="0"/>
-                          </a:rPr>
-                          <m:t>/</m:t>
-                        </m:r>
-                        <m:r>
-                          <a:rPr>
-                            <a:latin typeface="Cambria Math" panose="02040503050406030204" pitchFamily="18" charset="0"/>
-                          </a:rPr>
-                          <m:t>𝑑𝑥</m:t>
-                        </m:r>
-                        <m:r>
-                          <a:rPr>
-                            <a:latin typeface="Cambria Math" panose="02040503050406030204" pitchFamily="18" charset="0"/>
-                          </a:rPr>
-                          <m:t>=</m:t>
-                        </m:r>
-                        <m:r>
-                          <m:rPr>
-                            <m:sty m:val="p"/>
-                          </m:rPr>
-                          <a:rPr>
-                            <a:latin typeface="Cambria Math" panose="02040503050406030204" pitchFamily="18" charset="0"/>
-                          </a:rPr>
-                          <m:t>sin</m:t>
-                        </m:r>
-                        <m:r>
-                          <a:rPr>
-                            <a:latin typeface="Cambria Math" panose="02040503050406030204" pitchFamily="18" charset="0"/>
-                          </a:rPr>
-                          <m:t>(</m:t>
-                        </m:r>
-                        <m:r>
-                          <a:rPr>
-                            <a:latin typeface="Cambria Math" panose="02040503050406030204" pitchFamily="18" charset="0"/>
-                          </a:rPr>
-                          <m:t>𝑥</m:t>
-                        </m:r>
-                        <m:r>
-                          <a:rPr>
-                            <a:latin typeface="Cambria Math" panose="02040503050406030204" pitchFamily="18" charset="0"/>
-                          </a:rPr>
-                          <m:t>+</m:t>
-                        </m:r>
-                        <m:r>
-                          <a:rPr>
-                            <a:latin typeface="Cambria Math" panose="02040503050406030204" pitchFamily="18" charset="0"/>
-                          </a:rPr>
-                          <m:t>𝑦</m:t>
-                        </m:r>
-                        <m:r>
-                          <a:rPr>
-                            <a:latin typeface="Cambria Math" panose="02040503050406030204" pitchFamily="18" charset="0"/>
-                          </a:rPr>
-                          <m:t>)</m:t>
-                        </m:r>
-                      </m:oMath>
-                    </a14:m>
-                  </mc:Choice>
-                  <mc:Fallback xmlns="">
-                    <a:r>
-                      <a:rPr lang="es-MX" sz="1250">
-                        <a:solidFill>
-                          <a:srgbClr val="9F1239"/>
-                        </a:solidFill>
+                <a14:m>
+                  <m:oMath xmlns:m="http://schemas.openxmlformats.org/officeDocument/2006/math">
+                    <m:r>
+                      <a:rPr>
+                        <a:latin typeface="Cambria Math" panose="02040503050406030204" pitchFamily="18" charset="0"/>
                       </a:rPr>
-                      <a:t>dy/dx = \sin(x+y)</a:t>
-                    </a:r>
-                  </mc:Fallback>
-                </mc:AlternateContent>
+                      <m:t>𝑑𝑦</m:t>
+                    </m:r>
+                    <m:r>
+                      <a:rPr>
+                        <a:latin typeface="Cambria Math" panose="02040503050406030204" pitchFamily="18" charset="0"/>
+                      </a:rPr>
+                      <m:t>/</m:t>
+                    </m:r>
+                    <m:r>
+                      <a:rPr>
+                        <a:latin typeface="Cambria Math" panose="02040503050406030204" pitchFamily="18" charset="0"/>
+                      </a:rPr>
+                      <m:t>𝑑𝑥</m:t>
+                    </m:r>
+                    <m:r>
+                      <a:rPr>
+                        <a:latin typeface="Cambria Math" panose="02040503050406030204" pitchFamily="18" charset="0"/>
+                      </a:rPr>
+                      <m:t>=</m:t>
+                    </m:r>
+                    <m:r>
+                      <m:rPr>
+                        <m:sty m:val="p"/>
+                      </m:rPr>
+                      <a:rPr>
+                        <a:latin typeface="Cambria Math" panose="02040503050406030204" pitchFamily="18" charset="0"/>
+                      </a:rPr>
+                      <m:t>sin</m:t>
+                    </m:r>
+                    <m:r>
+                      <a:rPr>
+                        <a:latin typeface="Cambria Math" panose="02040503050406030204" pitchFamily="18" charset="0"/>
+                      </a:rPr>
+                      <m:t>(</m:t>
+                    </m:r>
+                    <m:r>
+                      <a:rPr>
+                        <a:latin typeface="Cambria Math" panose="02040503050406030204" pitchFamily="18" charset="0"/>
+                      </a:rPr>
+                      <m:t>𝑥</m:t>
+                    </m:r>
+                    <m:r>
+                      <a:rPr>
+                        <a:latin typeface="Cambria Math" panose="02040503050406030204" pitchFamily="18" charset="0"/>
+                      </a:rPr>
+                      <m:t>+</m:t>
+                    </m:r>
+                    <m:r>
+                      <a:rPr>
+                        <a:latin typeface="Cambria Math" panose="02040503050406030204" pitchFamily="18" charset="0"/>
+                      </a:rPr>
+                      <m:t>𝑦</m:t>
+                    </m:r>
+                    <m:r>
+                      <a:rPr>
+                        <a:latin typeface="Cambria Math" panose="02040503050406030204" pitchFamily="18" charset="0"/>
+                      </a:rPr>
+                      <m:t>)</m:t>
+                    </m:r>
+                  </m:oMath>
+                </a14:m>
                 <a:r>
                   <a:rPr lang="en-US" sz="1250" dirty="0">
                     <a:solidFill>
@@ -15659,7 +15477,7 @@
             </p:txBody>
           </p:sp>
         </mc:Choice>
-        <mc:Fallback>
+        <mc:Fallback xmlns="">
           <p:sp>
             <p:nvSpPr>
               <p:cNvPr id="21" name="Text 19"/>
@@ -16056,8 +15874,8 @@
           </a:p>
         </p:txBody>
       </p:sp>
-      <mc:AlternateContent xmlns:mc="http://schemas.openxmlformats.org/markup-compatibility/2006">
-        <mc:Choice xmlns:a14="http://schemas.microsoft.com/office/drawing/2010/main" Requires="a14">
+      <mc:AlternateContent xmlns:mc="http://schemas.openxmlformats.org/markup-compatibility/2006" xmlns:a14="http://schemas.microsoft.com/office/drawing/2010/main">
+        <mc:Choice Requires="a14">
           <p:sp>
             <p:nvSpPr>
               <p:cNvPr id="10" name="Text 8"/>
@@ -16313,7 +16131,7 @@
             </p:txBody>
           </p:sp>
         </mc:Choice>
-        <mc:Fallback>
+        <mc:Fallback xmlns="">
           <p:sp>
             <p:nvSpPr>
               <p:cNvPr id="10" name="Text 8"/>
@@ -16492,8 +16310,8 @@
           </a:p>
         </p:txBody>
       </p:sp>
-      <mc:AlternateContent xmlns:mc="http://schemas.openxmlformats.org/markup-compatibility/2006">
-        <mc:Choice xmlns:a14="http://schemas.microsoft.com/office/drawing/2010/main" Requires="a14">
+      <mc:AlternateContent xmlns:mc="http://schemas.openxmlformats.org/markup-compatibility/2006" xmlns:a14="http://schemas.microsoft.com/office/drawing/2010/main">
+        <mc:Choice Requires="a14">
           <p:sp>
             <p:nvSpPr>
               <p:cNvPr id="15" name="Text 13"/>
@@ -16643,7 +16461,7 @@
             </p:txBody>
           </p:sp>
         </mc:Choice>
-        <mc:Fallback>
+        <mc:Fallback xmlns="">
           <p:sp>
             <p:nvSpPr>
               <p:cNvPr id="15" name="Text 13"/>
@@ -16822,8 +16640,8 @@
           </a:p>
         </p:txBody>
       </p:sp>
-      <mc:AlternateContent xmlns:mc="http://schemas.openxmlformats.org/markup-compatibility/2006">
-        <mc:Choice xmlns:a14="http://schemas.microsoft.com/office/drawing/2010/main" Requires="a14">
+      <mc:AlternateContent xmlns:mc="http://schemas.openxmlformats.org/markup-compatibility/2006" xmlns:a14="http://schemas.microsoft.com/office/drawing/2010/main">
+        <mc:Choice Requires="a14">
           <p:sp>
             <p:nvSpPr>
               <p:cNvPr id="20" name="Text 18"/>
@@ -16941,7 +16759,7 @@
             </p:txBody>
           </p:sp>
         </mc:Choice>
-        <mc:Fallback>
+        <mc:Fallback xmlns="">
           <p:sp>
             <p:nvSpPr>
               <p:cNvPr id="20" name="Text 18"/>
@@ -17120,8 +16938,8 @@
           </a:p>
         </p:txBody>
       </p:sp>
-      <mc:AlternateContent xmlns:mc="http://schemas.openxmlformats.org/markup-compatibility/2006">
-        <mc:Choice xmlns:a14="http://schemas.microsoft.com/office/drawing/2010/main" Requires="a14">
+      <mc:AlternateContent xmlns:mc="http://schemas.openxmlformats.org/markup-compatibility/2006" xmlns:a14="http://schemas.microsoft.com/office/drawing/2010/main">
+        <mc:Choice Requires="a14">
           <p:sp>
             <p:nvSpPr>
               <p:cNvPr id="25" name="Text 23"/>
@@ -17209,7 +17027,7 @@
             </p:txBody>
           </p:sp>
         </mc:Choice>
-        <mc:Fallback>
+        <mc:Fallback xmlns="">
           <p:sp>
             <p:nvSpPr>
               <p:cNvPr id="25" name="Text 23"/>
@@ -17283,8 +17101,8 @@
           </a:p>
         </p:txBody>
       </p:sp>
-      <mc:AlternateContent xmlns:mc="http://schemas.openxmlformats.org/markup-compatibility/2006">
-        <mc:Choice xmlns:a14="http://schemas.microsoft.com/office/drawing/2010/main" Requires="a14">
+      <mc:AlternateContent xmlns:mc="http://schemas.openxmlformats.org/markup-compatibility/2006" xmlns:a14="http://schemas.microsoft.com/office/drawing/2010/main">
+        <mc:Choice Requires="a14">
           <p:sp>
             <p:nvSpPr>
               <p:cNvPr id="27" name="Text 25"/>
@@ -17404,7 +17222,7 @@
             </p:txBody>
           </p:sp>
         </mc:Choice>
-        <mc:Fallback>
+        <mc:Fallback xmlns="">
           <p:sp>
             <p:nvSpPr>
               <p:cNvPr id="27" name="Text 25"/>
@@ -17478,8 +17296,8 @@
           </a:p>
         </p:txBody>
       </p:sp>
-      <mc:AlternateContent xmlns:mc="http://schemas.openxmlformats.org/markup-compatibility/2006">
-        <mc:Choice xmlns:a14="http://schemas.microsoft.com/office/drawing/2010/main" Requires="a14">
+      <mc:AlternateContent xmlns:mc="http://schemas.openxmlformats.org/markup-compatibility/2006" xmlns:a14="http://schemas.microsoft.com/office/drawing/2010/main">
+        <mc:Choice Requires="a14">
           <p:sp>
             <p:nvSpPr>
               <p:cNvPr id="29" name="Text 27"/>
@@ -17617,7 +17435,7 @@
             </p:txBody>
           </p:sp>
         </mc:Choice>
-        <mc:Fallback>
+        <mc:Fallback xmlns="">
           <p:sp>
             <p:nvSpPr>
               <p:cNvPr id="29" name="Text 27"/>
@@ -17940,8 +17758,8 @@
           </a:p>
         </p:txBody>
       </p:sp>
-      <mc:AlternateContent xmlns:mc="http://schemas.openxmlformats.org/markup-compatibility/2006">
-        <mc:Choice xmlns:a14="http://schemas.microsoft.com/office/drawing/2010/main" Requires="a14">
+      <mc:AlternateContent xmlns:mc="http://schemas.openxmlformats.org/markup-compatibility/2006" xmlns:a14="http://schemas.microsoft.com/office/drawing/2010/main">
+        <mc:Choice Requires="a14">
           <p:sp>
             <p:nvSpPr>
               <p:cNvPr id="7" name="Text 5"/>
@@ -18024,7 +17842,7 @@
             </p:txBody>
           </p:sp>
         </mc:Choice>
-        <mc:Fallback>
+        <mc:Fallback xmlns="">
           <p:sp>
             <p:nvSpPr>
               <p:cNvPr id="7" name="Text 5"/>
@@ -18285,8 +18103,8 @@
           </a:p>
         </p:txBody>
       </p:sp>
-      <mc:AlternateContent xmlns:mc="http://schemas.openxmlformats.org/markup-compatibility/2006">
-        <mc:Choice xmlns:a14="http://schemas.microsoft.com/office/drawing/2010/main" Requires="a14">
+      <mc:AlternateContent xmlns:mc="http://schemas.openxmlformats.org/markup-compatibility/2006" xmlns:a14="http://schemas.microsoft.com/office/drawing/2010/main">
+        <mc:Choice Requires="a14">
           <p:sp>
             <p:nvSpPr>
               <p:cNvPr id="5" name="Text 3"/>
@@ -18369,7 +18187,7 @@
             </p:txBody>
           </p:sp>
         </mc:Choice>
-        <mc:Fallback>
+        <mc:Fallback xmlns="">
           <p:sp>
             <p:nvSpPr>
               <p:cNvPr id="5" name="Text 3"/>
@@ -18482,8 +18300,8 @@
           </a:p>
         </p:txBody>
       </p:sp>
-      <mc:AlternateContent xmlns:mc="http://schemas.openxmlformats.org/markup-compatibility/2006">
-        <mc:Choice xmlns:a14="http://schemas.microsoft.com/office/drawing/2010/main" Requires="a14">
+      <mc:AlternateContent xmlns:mc="http://schemas.openxmlformats.org/markup-compatibility/2006" xmlns:a14="http://schemas.microsoft.com/office/drawing/2010/main">
+        <mc:Choice Requires="a14">
           <p:sp>
             <p:nvSpPr>
               <p:cNvPr id="8" name="Text 6"/>
@@ -18560,7 +18378,7 @@
             </p:txBody>
           </p:sp>
         </mc:Choice>
-        <mc:Fallback>
+        <mc:Fallback xmlns="">
           <p:sp>
             <p:nvSpPr>
               <p:cNvPr id="8" name="Text 6"/>
@@ -18634,8 +18452,8 @@
           </a:p>
         </p:txBody>
       </p:sp>
-      <mc:AlternateContent xmlns:mc="http://schemas.openxmlformats.org/markup-compatibility/2006">
-        <mc:Choice xmlns:a14="http://schemas.microsoft.com/office/drawing/2010/main" Requires="a14">
+      <mc:AlternateContent xmlns:mc="http://schemas.openxmlformats.org/markup-compatibility/2006" xmlns:a14="http://schemas.microsoft.com/office/drawing/2010/main">
+        <mc:Choice Requires="a14">
           <p:sp>
             <p:nvSpPr>
               <p:cNvPr id="10" name="Text 8"/>
@@ -18738,7 +18556,7 @@
             </p:txBody>
           </p:sp>
         </mc:Choice>
-        <mc:Fallback>
+        <mc:Fallback xmlns="">
           <p:sp>
             <p:nvSpPr>
               <p:cNvPr id="10" name="Text 8"/>
@@ -18859,8 +18677,8 @@
           </a:p>
         </p:txBody>
       </p:sp>
-      <mc:AlternateContent xmlns:mc="http://schemas.openxmlformats.org/markup-compatibility/2006">
-        <mc:Choice xmlns:a14="http://schemas.microsoft.com/office/drawing/2010/main" Requires="a14">
+      <mc:AlternateContent xmlns:mc="http://schemas.openxmlformats.org/markup-compatibility/2006" xmlns:a14="http://schemas.microsoft.com/office/drawing/2010/main">
+        <mc:Choice Requires="a14">
           <p:sp>
             <p:nvSpPr>
               <p:cNvPr id="13" name="Text 11"/>
@@ -18980,7 +18798,7 @@
             </p:txBody>
           </p:sp>
         </mc:Choice>
-        <mc:Fallback>
+        <mc:Fallback xmlns="">
           <p:sp>
             <p:nvSpPr>
               <p:cNvPr id="13" name="Text 11"/>
@@ -19149,8 +18967,8 @@
           </a:p>
         </p:txBody>
       </p:sp>
-      <mc:AlternateContent xmlns:mc="http://schemas.openxmlformats.org/markup-compatibility/2006">
-        <mc:Choice xmlns:a14="http://schemas.microsoft.com/office/drawing/2010/main" Requires="a14">
+      <mc:AlternateContent xmlns:mc="http://schemas.openxmlformats.org/markup-compatibility/2006" xmlns:a14="http://schemas.microsoft.com/office/drawing/2010/main">
+        <mc:Choice Requires="a14">
           <p:sp>
             <p:nvSpPr>
               <p:cNvPr id="17" name="Text 15"/>
@@ -19227,7 +19045,7 @@
             </p:txBody>
           </p:sp>
         </mc:Choice>
-        <mc:Fallback>
+        <mc:Fallback xmlns="">
           <p:sp>
             <p:nvSpPr>
               <p:cNvPr id="17" name="Text 15"/>
@@ -19510,8 +19328,8 @@
           </a:p>
         </p:txBody>
       </p:sp>
-      <mc:AlternateContent xmlns:mc="http://schemas.openxmlformats.org/markup-compatibility/2006">
-        <mc:Choice xmlns:a14="http://schemas.microsoft.com/office/drawing/2010/main" Requires="a14">
+      <mc:AlternateContent xmlns:mc="http://schemas.openxmlformats.org/markup-compatibility/2006" xmlns:a14="http://schemas.microsoft.com/office/drawing/2010/main">
+        <mc:Choice Requires="a14">
           <p:sp>
             <p:nvSpPr>
               <p:cNvPr id="7" name="Text 5"/>
@@ -19638,7 +19456,7 @@
             </p:txBody>
           </p:sp>
         </mc:Choice>
-        <mc:Fallback>
+        <mc:Fallback xmlns="">
           <p:sp>
             <p:nvSpPr>
               <p:cNvPr id="7" name="Text 5"/>
@@ -19899,8 +19717,8 @@
           </a:p>
         </p:txBody>
       </p:sp>
-      <mc:AlternateContent xmlns:mc="http://schemas.openxmlformats.org/markup-compatibility/2006">
-        <mc:Choice xmlns:a14="http://schemas.microsoft.com/office/drawing/2010/main" Requires="a14">
+      <mc:AlternateContent xmlns:mc="http://schemas.openxmlformats.org/markup-compatibility/2006" xmlns:a14="http://schemas.microsoft.com/office/drawing/2010/main">
+        <mc:Choice Requires="a14">
           <p:sp>
             <p:nvSpPr>
               <p:cNvPr id="5" name="Text 3"/>
@@ -20021,7 +19839,7 @@
             </p:txBody>
           </p:sp>
         </mc:Choice>
-        <mc:Fallback>
+        <mc:Fallback xmlns="">
           <p:sp>
             <p:nvSpPr>
               <p:cNvPr id="5" name="Text 3"/>
@@ -20134,8 +19952,8 @@
           </a:p>
         </p:txBody>
       </p:sp>
-      <mc:AlternateContent xmlns:mc="http://schemas.openxmlformats.org/markup-compatibility/2006">
-        <mc:Choice xmlns:a14="http://schemas.microsoft.com/office/drawing/2010/main" Requires="a14">
+      <mc:AlternateContent xmlns:mc="http://schemas.openxmlformats.org/markup-compatibility/2006" xmlns:a14="http://schemas.microsoft.com/office/drawing/2010/main">
+        <mc:Choice Requires="a14">
           <p:sp>
             <p:nvSpPr>
               <p:cNvPr id="8" name="Text 6"/>
@@ -20194,7 +20012,7 @@
             </p:txBody>
           </p:sp>
         </mc:Choice>
-        <mc:Fallback>
+        <mc:Fallback xmlns="">
           <p:sp>
             <p:nvSpPr>
               <p:cNvPr id="8" name="Text 6"/>
@@ -20268,8 +20086,8 @@
           </a:p>
         </p:txBody>
       </p:sp>
-      <mc:AlternateContent xmlns:mc="http://schemas.openxmlformats.org/markup-compatibility/2006">
-        <mc:Choice xmlns:a14="http://schemas.microsoft.com/office/drawing/2010/main" Requires="a14">
+      <mc:AlternateContent xmlns:mc="http://schemas.openxmlformats.org/markup-compatibility/2006" xmlns:a14="http://schemas.microsoft.com/office/drawing/2010/main">
+        <mc:Choice Requires="a14">
           <p:sp>
             <p:nvSpPr>
               <p:cNvPr id="10" name="Text 8"/>
@@ -20305,7 +20123,7 @@
                       <m:f>
                         <m:fPr>
                           <m:ctrlPr>
-                            <a:rPr>
+                            <a:rPr i="1">
                               <a:latin typeface="Cambria Math" panose="02040503050406030204" pitchFamily="18" charset="0"/>
                             </a:rPr>
                           </m:ctrlPr>
@@ -20416,7 +20234,7 @@
             </p:txBody>
           </p:sp>
         </mc:Choice>
-        <mc:Fallback>
+        <mc:Fallback xmlns="">
           <p:sp>
             <p:nvSpPr>
               <p:cNvPr id="10" name="Text 8"/>
@@ -20456,8 +20274,8 @@
           </p:sp>
         </mc:Fallback>
       </mc:AlternateContent>
-      <mc:AlternateContent xmlns:mc="http://schemas.openxmlformats.org/markup-compatibility/2006">
-        <mc:Choice xmlns:a14="http://schemas.microsoft.com/office/drawing/2010/main" Requires="a14">
+      <mc:AlternateContent xmlns:mc="http://schemas.openxmlformats.org/markup-compatibility/2006" xmlns:a14="http://schemas.microsoft.com/office/drawing/2010/main">
+        <mc:Choice Requires="a14">
           <p:sp>
             <p:nvSpPr>
               <p:cNvPr id="11" name="Text 9"/>
@@ -20575,7 +20393,7 @@
             </p:txBody>
           </p:sp>
         </mc:Choice>
-        <mc:Fallback>
+        <mc:Fallback xmlns="">
           <p:sp>
             <p:nvSpPr>
               <p:cNvPr id="11" name="Text 9"/>
@@ -20688,8 +20506,8 @@
           </a:p>
         </p:txBody>
       </p:sp>
-      <mc:AlternateContent xmlns:mc="http://schemas.openxmlformats.org/markup-compatibility/2006">
-        <mc:Choice xmlns:a14="http://schemas.microsoft.com/office/drawing/2010/main" Requires="a14">
+      <mc:AlternateContent xmlns:mc="http://schemas.openxmlformats.org/markup-compatibility/2006" xmlns:a14="http://schemas.microsoft.com/office/drawing/2010/main">
+        <mc:Choice Requires="a14">
           <p:sp>
             <p:nvSpPr>
               <p:cNvPr id="14" name="Text 12"/>
@@ -20792,7 +20610,7 @@
             </p:txBody>
           </p:sp>
         </mc:Choice>
-        <mc:Fallback>
+        <mc:Fallback xmlns="">
           <p:sp>
             <p:nvSpPr>
               <p:cNvPr id="14" name="Text 12"/>
@@ -20905,8 +20723,8 @@
           </a:p>
         </p:txBody>
       </p:sp>
-      <mc:AlternateContent xmlns:mc="http://schemas.openxmlformats.org/markup-compatibility/2006">
-        <mc:Choice xmlns:a14="http://schemas.microsoft.com/office/drawing/2010/main" Requires="a14">
+      <mc:AlternateContent xmlns:mc="http://schemas.openxmlformats.org/markup-compatibility/2006" xmlns:a14="http://schemas.microsoft.com/office/drawing/2010/main">
+        <mc:Choice Requires="a14">
           <p:sp>
             <p:nvSpPr>
               <p:cNvPr id="17" name="Text 15"/>
@@ -21009,7 +20827,7 @@
             </p:txBody>
           </p:sp>
         </mc:Choice>
-        <mc:Fallback>
+        <mc:Fallback xmlns="">
           <p:sp>
             <p:nvSpPr>
               <p:cNvPr id="17" name="Text 15"/>
@@ -21262,8 +21080,8 @@
           </a:p>
         </p:txBody>
       </p:sp>
-      <mc:AlternateContent xmlns:mc="http://schemas.openxmlformats.org/markup-compatibility/2006">
-        <mc:Choice xmlns:a14="http://schemas.microsoft.com/office/drawing/2010/main" Requires="a14">
+      <mc:AlternateContent xmlns:mc="http://schemas.openxmlformats.org/markup-compatibility/2006" xmlns:a14="http://schemas.microsoft.com/office/drawing/2010/main">
+        <mc:Choice Requires="a14">
           <p:sp>
             <p:nvSpPr>
               <p:cNvPr id="6" name="Text 4"/>
@@ -21487,7 +21305,7 @@
             </p:txBody>
           </p:sp>
         </mc:Choice>
-        <mc:Fallback>
+        <mc:Fallback xmlns="">
           <p:sp>
             <p:nvSpPr>
               <p:cNvPr id="6" name="Text 4"/>
@@ -21561,8 +21379,8 @@
           </a:p>
         </p:txBody>
       </p:sp>
-      <mc:AlternateContent xmlns:mc="http://schemas.openxmlformats.org/markup-compatibility/2006">
-        <mc:Choice xmlns:a14="http://schemas.microsoft.com/office/drawing/2010/main" Requires="a14">
+      <mc:AlternateContent xmlns:mc="http://schemas.openxmlformats.org/markup-compatibility/2006" xmlns:a14="http://schemas.microsoft.com/office/drawing/2010/main">
+        <mc:Choice Requires="a14">
           <p:sp>
             <p:nvSpPr>
               <p:cNvPr id="8" name="Text 6"/>
@@ -21659,7 +21477,7 @@
             </p:txBody>
           </p:sp>
         </mc:Choice>
-        <mc:Fallback>
+        <mc:Fallback xmlns="">
           <p:sp>
             <p:nvSpPr>
               <p:cNvPr id="8" name="Text 6"/>
@@ -21699,8 +21517,8 @@
           </p:sp>
         </mc:Fallback>
       </mc:AlternateContent>
-      <mc:AlternateContent xmlns:mc="http://schemas.openxmlformats.org/markup-compatibility/2006">
-        <mc:Choice xmlns:a14="http://schemas.microsoft.com/office/drawing/2010/main" Requires="a14">
+      <mc:AlternateContent xmlns:mc="http://schemas.openxmlformats.org/markup-compatibility/2006" xmlns:a14="http://schemas.microsoft.com/office/drawing/2010/main">
+        <mc:Choice Requires="a14">
           <p:sp>
             <p:nvSpPr>
               <p:cNvPr id="9" name="Text 7"/>
@@ -21933,7 +21751,7 @@
             </p:txBody>
           </p:sp>
         </mc:Choice>
-        <mc:Fallback>
+        <mc:Fallback xmlns="">
           <p:sp>
             <p:nvSpPr>
               <p:cNvPr id="9" name="Text 7"/>
@@ -22002,8 +21820,8 @@
           </a:p>
         </p:txBody>
       </p:sp>
-      <mc:AlternateContent xmlns:mc="http://schemas.openxmlformats.org/markup-compatibility/2006">
-        <mc:Choice xmlns:a14="http://schemas.microsoft.com/office/drawing/2010/main" Requires="a14">
+      <mc:AlternateContent xmlns:mc="http://schemas.openxmlformats.org/markup-compatibility/2006" xmlns:a14="http://schemas.microsoft.com/office/drawing/2010/main">
+        <mc:Choice Requires="a14">
           <p:sp>
             <p:nvSpPr>
               <p:cNvPr id="11" name="Text 9"/>
@@ -22101,7 +21919,7 @@
             </p:txBody>
           </p:sp>
         </mc:Choice>
-        <mc:Fallback>
+        <mc:Fallback xmlns="">
           <p:sp>
             <p:nvSpPr>
               <p:cNvPr id="11" name="Text 9"/>
@@ -22342,8 +22160,8 @@
           </a:p>
         </p:txBody>
       </p:sp>
-      <mc:AlternateContent xmlns:mc="http://schemas.openxmlformats.org/markup-compatibility/2006">
-        <mc:Choice xmlns:a14="http://schemas.microsoft.com/office/drawing/2010/main" Requires="a14">
+      <mc:AlternateContent xmlns:mc="http://schemas.openxmlformats.org/markup-compatibility/2006" xmlns:a14="http://schemas.microsoft.com/office/drawing/2010/main">
+        <mc:Choice Requires="a14">
           <p:sp>
             <p:nvSpPr>
               <p:cNvPr id="7" name="Text 5"/>
@@ -22458,7 +22276,7 @@
             </p:txBody>
           </p:sp>
         </mc:Choice>
-        <mc:Fallback>
+        <mc:Fallback xmlns="">
           <p:sp>
             <p:nvSpPr>
               <p:cNvPr id="7" name="Text 5"/>

</xml_diff>